<commit_message>
Draft of presentation with speaker notes
</commit_message>
<xml_diff>
--- a/P0/Dissemination/P0_Presentation.pptx
+++ b/P0/Dissemination/P0_Presentation.pptx
@@ -4,6 +4,9 @@
   <p:sldMasterIdLst>
     <p:sldMasterId id="2147483648" r:id="rId1"/>
   </p:sldMasterIdLst>
+  <p:notesMasterIdLst>
+    <p:notesMasterId r:id="rId9"/>
+  </p:notesMasterIdLst>
   <p:sldIdLst>
     <p:sldId id="256" r:id="rId2"/>
     <p:sldId id="257" r:id="rId3"/>
@@ -12,7 +15,6 @@
     <p:sldId id="260" r:id="rId6"/>
     <p:sldId id="261" r:id="rId7"/>
     <p:sldId id="262" r:id="rId8"/>
-    <p:sldId id="263" r:id="rId9"/>
   </p:sldIdLst>
   <p:sldSz cx="12192000" cy="6858000"/>
   <p:notesSz cx="6858000" cy="9144000"/>
@@ -111,26 +113,186 @@
       </a:defRPr>
     </a:lvl9pPr>
   </p:defaultTextStyle>
+  <p:extLst>
+    <p:ext uri="{EFAFB233-063F-42B5-8137-9DF3F51BA10A}">
+      <p15:sldGuideLst xmlns:p15="http://schemas.microsoft.com/office/powerpoint/2012/main"/>
+    </p:ext>
+  </p:extLst>
 </p:presentation>
+</file>
+
+<file path=ppt/revisionInfo.xml><?xml version="1.0" encoding="utf-8"?>
+<p1510:revInfo xmlns:a="http://schemas.openxmlformats.org/drawingml/2006/main" xmlns:r="http://schemas.openxmlformats.org/officeDocument/2006/relationships" xmlns:p1510="http://schemas.microsoft.com/office/powerpoint/2015/10/main">
+  <p1510:revLst>
+    <p1510:client id="{4C51E5A6-39C2-4CA6-8E0B-2F98A1D41BD3}" v="56" dt="2026-02-04T07:44:22.720"/>
+  </p1510:revLst>
+</p1510:revInfo>
 </file>
 
 <file path=ppt/changesInfos/changesInfo1.xml><?xml version="1.0" encoding="utf-8"?>
 <pc:chgInfo xmlns:a="http://schemas.openxmlformats.org/drawingml/2006/main" xmlns:r="http://schemas.openxmlformats.org/officeDocument/2006/relationships" xmlns:ac="http://schemas.microsoft.com/office/drawing/2013/main/command" xmlns:pc="http://schemas.microsoft.com/office/powerpoint/2013/main/command">
   <pc:docChgLst>
     <pc:chgData name="Ezra Weible" userId="67bcaf2f89c4552e" providerId="LiveId" clId="{E4E19776-AA89-4579-B0CB-50FEF10C4E93}"/>
-    <pc:docChg chg="modSld">
-      <pc:chgData name="Ezra Weible" userId="67bcaf2f89c4552e" providerId="LiveId" clId="{E4E19776-AA89-4579-B0CB-50FEF10C4E93}" dt="2026-02-03T21:03:31.553" v="1" actId="1076"/>
+    <pc:docChg chg="undo custSel delSld modSld">
+      <pc:chgData name="Ezra Weible" userId="67bcaf2f89c4552e" providerId="LiveId" clId="{E4E19776-AA89-4579-B0CB-50FEF10C4E93}" dt="2026-02-04T07:44:27.332" v="787"/>
       <pc:docMkLst>
         <pc:docMk/>
       </pc:docMkLst>
       <pc:sldChg chg="modSp mod">
-        <pc:chgData name="Ezra Weible" userId="67bcaf2f89c4552e" providerId="LiveId" clId="{E4E19776-AA89-4579-B0CB-50FEF10C4E93}" dt="2026-02-03T21:03:31.553" v="1" actId="1076"/>
+        <pc:chgData name="Ezra Weible" userId="67bcaf2f89c4552e" providerId="LiveId" clId="{E4E19776-AA89-4579-B0CB-50FEF10C4E93}" dt="2026-02-04T07:20:15.341" v="42" actId="20577"/>
+        <pc:sldMkLst>
+          <pc:docMk/>
+          <pc:sldMk cId="798666000" sldId="256"/>
+        </pc:sldMkLst>
+        <pc:spChg chg="mod">
+          <ac:chgData name="Ezra Weible" userId="67bcaf2f89c4552e" providerId="LiveId" clId="{E4E19776-AA89-4579-B0CB-50FEF10C4E93}" dt="2026-02-04T07:19:58.703" v="4" actId="27636"/>
+          <ac:spMkLst>
+            <pc:docMk/>
+            <pc:sldMk cId="798666000" sldId="256"/>
+            <ac:spMk id="2" creationId="{6EC56CB9-0C0D-8ED2-2C55-0D9ED6720E2C}"/>
+          </ac:spMkLst>
+        </pc:spChg>
+        <pc:spChg chg="mod">
+          <ac:chgData name="Ezra Weible" userId="67bcaf2f89c4552e" providerId="LiveId" clId="{E4E19776-AA89-4579-B0CB-50FEF10C4E93}" dt="2026-02-04T07:20:15.341" v="42" actId="20577"/>
+          <ac:spMkLst>
+            <pc:docMk/>
+            <pc:sldMk cId="798666000" sldId="256"/>
+            <ac:spMk id="3" creationId="{40676103-CEFF-EEF2-9BFF-93AD8B085821}"/>
+          </ac:spMkLst>
+        </pc:spChg>
+      </pc:sldChg>
+      <pc:sldChg chg="modSp mod">
+        <pc:chgData name="Ezra Weible" userId="67bcaf2f89c4552e" providerId="LiveId" clId="{E4E19776-AA89-4579-B0CB-50FEF10C4E93}" dt="2026-02-04T07:23:15.438" v="71" actId="20577"/>
+        <pc:sldMkLst>
+          <pc:docMk/>
+          <pc:sldMk cId="441426594" sldId="257"/>
+        </pc:sldMkLst>
+        <pc:spChg chg="mod">
+          <ac:chgData name="Ezra Weible" userId="67bcaf2f89c4552e" providerId="LiveId" clId="{E4E19776-AA89-4579-B0CB-50FEF10C4E93}" dt="2026-02-04T07:20:31.255" v="50" actId="20577"/>
+          <ac:spMkLst>
+            <pc:docMk/>
+            <pc:sldMk cId="441426594" sldId="257"/>
+            <ac:spMk id="2" creationId="{757687EE-62FE-DC97-71A3-07EA94F14F70}"/>
+          </ac:spMkLst>
+        </pc:spChg>
+        <pc:spChg chg="mod">
+          <ac:chgData name="Ezra Weible" userId="67bcaf2f89c4552e" providerId="LiveId" clId="{E4E19776-AA89-4579-B0CB-50FEF10C4E93}" dt="2026-02-04T07:23:15.438" v="71" actId="20577"/>
+          <ac:spMkLst>
+            <pc:docMk/>
+            <pc:sldMk cId="441426594" sldId="257"/>
+            <ac:spMk id="3" creationId="{7B0ED94B-8BFA-9A98-3F9D-86FA4160A50B}"/>
+          </ac:spMkLst>
+        </pc:spChg>
+      </pc:sldChg>
+      <pc:sldChg chg="addSp delSp modSp mod modNotesTx">
+        <pc:chgData name="Ezra Weible" userId="67bcaf2f89c4552e" providerId="LiveId" clId="{E4E19776-AA89-4579-B0CB-50FEF10C4E93}" dt="2026-02-04T07:40:02.280" v="638" actId="20577"/>
+        <pc:sldMkLst>
+          <pc:docMk/>
+          <pc:sldMk cId="1730044618" sldId="258"/>
+        </pc:sldMkLst>
+        <pc:spChg chg="del mod">
+          <ac:chgData name="Ezra Weible" userId="67bcaf2f89c4552e" providerId="LiveId" clId="{E4E19776-AA89-4579-B0CB-50FEF10C4E93}" dt="2026-02-04T07:22:42.782" v="53" actId="478"/>
+          <ac:spMkLst>
+            <pc:docMk/>
+            <pc:sldMk cId="1730044618" sldId="258"/>
+            <ac:spMk id="3" creationId="{FAFA35C1-F2C2-D64A-2CD8-A011B864D209}"/>
+          </ac:spMkLst>
+        </pc:spChg>
+        <pc:picChg chg="add mod">
+          <ac:chgData name="Ezra Weible" userId="67bcaf2f89c4552e" providerId="LiveId" clId="{E4E19776-AA89-4579-B0CB-50FEF10C4E93}" dt="2026-02-04T07:22:47.456" v="56" actId="1076"/>
+          <ac:picMkLst>
+            <pc:docMk/>
+            <pc:sldMk cId="1730044618" sldId="258"/>
+            <ac:picMk id="5" creationId="{B290F37E-41C6-B65E-54A3-38BFA37970FF}"/>
+          </ac:picMkLst>
+        </pc:picChg>
+      </pc:sldChg>
+      <pc:sldChg chg="modSp mod">
+        <pc:chgData name="Ezra Weible" userId="67bcaf2f89c4552e" providerId="LiveId" clId="{E4E19776-AA89-4579-B0CB-50FEF10C4E93}" dt="2026-02-04T07:35:18.585" v="333" actId="20577"/>
+        <pc:sldMkLst>
+          <pc:docMk/>
+          <pc:sldMk cId="4062194938" sldId="259"/>
+        </pc:sldMkLst>
+        <pc:spChg chg="mod">
+          <ac:chgData name="Ezra Weible" userId="67bcaf2f89c4552e" providerId="LiveId" clId="{E4E19776-AA89-4579-B0CB-50FEF10C4E93}" dt="2026-02-04T07:35:18.585" v="333" actId="20577"/>
+          <ac:spMkLst>
+            <pc:docMk/>
+            <pc:sldMk cId="4062194938" sldId="259"/>
+            <ac:spMk id="3" creationId="{2F642855-0B4B-2C12-1D6A-29B6870308FA}"/>
+          </ac:spMkLst>
+        </pc:spChg>
+      </pc:sldChg>
+      <pc:sldChg chg="modSp mod addAnim delAnim modAnim modNotesTx">
+        <pc:chgData name="Ezra Weible" userId="67bcaf2f89c4552e" providerId="LiveId" clId="{E4E19776-AA89-4579-B0CB-50FEF10C4E93}" dt="2026-02-04T07:44:17.229" v="785"/>
+        <pc:sldMkLst>
+          <pc:docMk/>
+          <pc:sldMk cId="2000768302" sldId="260"/>
+        </pc:sldMkLst>
+        <pc:spChg chg="mod">
+          <ac:chgData name="Ezra Weible" userId="67bcaf2f89c4552e" providerId="LiveId" clId="{E4E19776-AA89-4579-B0CB-50FEF10C4E93}" dt="2026-02-04T07:43:26.230" v="770" actId="20577"/>
+          <ac:spMkLst>
+            <pc:docMk/>
+            <pc:sldMk cId="2000768302" sldId="260"/>
+            <ac:spMk id="2" creationId="{3C32E293-491C-3824-19BB-FB7D5148EE42}"/>
+          </ac:spMkLst>
+        </pc:spChg>
+        <pc:picChg chg="mod">
+          <ac:chgData name="Ezra Weible" userId="67bcaf2f89c4552e" providerId="LiveId" clId="{E4E19776-AA89-4579-B0CB-50FEF10C4E93}" dt="2026-02-04T07:24:58.595" v="101" actId="14100"/>
+          <ac:picMkLst>
+            <pc:docMk/>
+            <pc:sldMk cId="2000768302" sldId="260"/>
+            <ac:picMk id="5" creationId="{9C89206C-813E-E0DC-8CC8-A2C5D8482A08}"/>
+          </ac:picMkLst>
+        </pc:picChg>
+        <pc:picChg chg="mod">
+          <ac:chgData name="Ezra Weible" userId="67bcaf2f89c4552e" providerId="LiveId" clId="{E4E19776-AA89-4579-B0CB-50FEF10C4E93}" dt="2026-02-04T07:24:53.336" v="99" actId="14100"/>
+          <ac:picMkLst>
+            <pc:docMk/>
+            <pc:sldMk cId="2000768302" sldId="260"/>
+            <ac:picMk id="7" creationId="{823BD01F-B2EA-0F16-E73A-7FB41A877705}"/>
+          </ac:picMkLst>
+        </pc:picChg>
+      </pc:sldChg>
+      <pc:sldChg chg="addSp delSp modSp mod addAnim delAnim modAnim modNotesTx">
+        <pc:chgData name="Ezra Weible" userId="67bcaf2f89c4552e" providerId="LiveId" clId="{E4E19776-AA89-4579-B0CB-50FEF10C4E93}" dt="2026-02-04T07:44:27.332" v="787"/>
         <pc:sldMkLst>
           <pc:docMk/>
           <pc:sldMk cId="2262919821" sldId="261"/>
         </pc:sldMkLst>
+        <pc:spChg chg="del">
+          <ac:chgData name="Ezra Weible" userId="67bcaf2f89c4552e" providerId="LiveId" clId="{E4E19776-AA89-4579-B0CB-50FEF10C4E93}" dt="2026-02-04T07:25:19.621" v="105" actId="478"/>
+          <ac:spMkLst>
+            <pc:docMk/>
+            <pc:sldMk cId="2262919821" sldId="261"/>
+            <ac:spMk id="2" creationId="{2A1B6C7D-E0EE-8D12-D0CC-F7E8C8E796E0}"/>
+          </ac:spMkLst>
+        </pc:spChg>
+        <pc:spChg chg="add mod">
+          <ac:chgData name="Ezra Weible" userId="67bcaf2f89c4552e" providerId="LiveId" clId="{E4E19776-AA89-4579-B0CB-50FEF10C4E93}" dt="2026-02-04T07:25:17.901" v="104"/>
+          <ac:spMkLst>
+            <pc:docMk/>
+            <pc:sldMk cId="2262919821" sldId="261"/>
+            <ac:spMk id="4" creationId="{CBBA4B84-1F4D-26DD-0426-608359E37931}"/>
+          </ac:spMkLst>
+        </pc:spChg>
+        <pc:spChg chg="add del mod">
+          <ac:chgData name="Ezra Weible" userId="67bcaf2f89c4552e" providerId="LiveId" clId="{E4E19776-AA89-4579-B0CB-50FEF10C4E93}" dt="2026-02-04T07:25:22.216" v="106" actId="478"/>
+          <ac:spMkLst>
+            <pc:docMk/>
+            <pc:sldMk cId="2262919821" sldId="261"/>
+            <ac:spMk id="8" creationId="{CA5D7CDE-D597-B9E3-9196-5C3247865658}"/>
+          </ac:spMkLst>
+        </pc:spChg>
+        <pc:spChg chg="add mod">
+          <ac:chgData name="Ezra Weible" userId="67bcaf2f89c4552e" providerId="LiveId" clId="{E4E19776-AA89-4579-B0CB-50FEF10C4E93}" dt="2026-02-04T07:43:32.055" v="781" actId="20577"/>
+          <ac:spMkLst>
+            <pc:docMk/>
+            <pc:sldMk cId="2262919821" sldId="261"/>
+            <ac:spMk id="9" creationId="{B56850CE-A908-F6A5-B025-26C864342C30}"/>
+          </ac:spMkLst>
+        </pc:spChg>
         <pc:picChg chg="mod">
-          <ac:chgData name="Ezra Weible" userId="67bcaf2f89c4552e" providerId="LiveId" clId="{E4E19776-AA89-4579-B0CB-50FEF10C4E93}" dt="2026-02-03T21:03:31.553" v="1" actId="1076"/>
+          <ac:chgData name="Ezra Weible" userId="67bcaf2f89c4552e" providerId="LiveId" clId="{E4E19776-AA89-4579-B0CB-50FEF10C4E93}" dt="2026-02-04T07:25:28.303" v="109" actId="14100"/>
           <ac:picMkLst>
             <pc:docMk/>
             <pc:sldMk cId="2262919821" sldId="261"/>
@@ -138,7 +300,7 @@
           </ac:picMkLst>
         </pc:picChg>
         <pc:picChg chg="mod">
-          <ac:chgData name="Ezra Weible" userId="67bcaf2f89c4552e" providerId="LiveId" clId="{E4E19776-AA89-4579-B0CB-50FEF10C4E93}" dt="2026-02-03T21:03:26.723" v="0" actId="1076"/>
+          <ac:chgData name="Ezra Weible" userId="67bcaf2f89c4552e" providerId="LiveId" clId="{E4E19776-AA89-4579-B0CB-50FEF10C4E93}" dt="2026-02-04T07:25:32.802" v="111" actId="14100"/>
           <ac:picMkLst>
             <pc:docMk/>
             <pc:sldMk cId="2262919821" sldId="261"/>
@@ -146,9 +308,861 @@
           </ac:picMkLst>
         </pc:picChg>
       </pc:sldChg>
+      <pc:sldChg chg="modSp mod modNotesTx">
+        <pc:chgData name="Ezra Weible" userId="67bcaf2f89c4552e" providerId="LiveId" clId="{E4E19776-AA89-4579-B0CB-50FEF10C4E93}" dt="2026-02-04T07:37:30.165" v="379" actId="20577"/>
+        <pc:sldMkLst>
+          <pc:docMk/>
+          <pc:sldMk cId="303442114" sldId="262"/>
+        </pc:sldMkLst>
+        <pc:spChg chg="mod">
+          <ac:chgData name="Ezra Weible" userId="67bcaf2f89c4552e" providerId="LiveId" clId="{E4E19776-AA89-4579-B0CB-50FEF10C4E93}" dt="2026-02-04T07:37:30.165" v="379" actId="20577"/>
+          <ac:spMkLst>
+            <pc:docMk/>
+            <pc:sldMk cId="303442114" sldId="262"/>
+            <ac:spMk id="2" creationId="{59865357-1D85-C3DF-63C3-85E0D823F1CA}"/>
+          </ac:spMkLst>
+        </pc:spChg>
+        <pc:spChg chg="mod">
+          <ac:chgData name="Ezra Weible" userId="67bcaf2f89c4552e" providerId="LiveId" clId="{E4E19776-AA89-4579-B0CB-50FEF10C4E93}" dt="2026-02-04T07:37:27.170" v="365" actId="20577"/>
+          <ac:spMkLst>
+            <pc:docMk/>
+            <pc:sldMk cId="303442114" sldId="262"/>
+            <ac:spMk id="3" creationId="{2DFE7377-DED7-C939-152E-FC777693251E}"/>
+          </ac:spMkLst>
+        </pc:spChg>
+      </pc:sldChg>
+      <pc:sldChg chg="del">
+        <pc:chgData name="Ezra Weible" userId="67bcaf2f89c4552e" providerId="LiveId" clId="{E4E19776-AA89-4579-B0CB-50FEF10C4E93}" dt="2026-02-04T07:19:37.527" v="2" actId="47"/>
+        <pc:sldMkLst>
+          <pc:docMk/>
+          <pc:sldMk cId="871395411" sldId="263"/>
+        </pc:sldMkLst>
+      </pc:sldChg>
     </pc:docChg>
   </pc:docChgLst>
 </pc:chgInfo>
+</file>
+
+<file path=ppt/notesMasters/notesMaster1.xml><?xml version="1.0" encoding="utf-8"?>
+<p:notesMaster xmlns:a="http://schemas.openxmlformats.org/drawingml/2006/main" xmlns:r="http://schemas.openxmlformats.org/officeDocument/2006/relationships" xmlns:p="http://schemas.openxmlformats.org/presentationml/2006/main">
+  <p:cSld>
+    <p:bg>
+      <p:bgRef idx="1001">
+        <a:schemeClr val="bg1"/>
+      </p:bgRef>
+    </p:bg>
+    <p:spTree>
+      <p:nvGrpSpPr>
+        <p:cNvPr id="1" name=""/>
+        <p:cNvGrpSpPr/>
+        <p:nvPr/>
+      </p:nvGrpSpPr>
+      <p:grpSpPr>
+        <a:xfrm>
+          <a:off x="0" y="0"/>
+          <a:ext cx="0" cy="0"/>
+          <a:chOff x="0" y="0"/>
+          <a:chExt cx="0" cy="0"/>
+        </a:xfrm>
+      </p:grpSpPr>
+      <p:sp>
+        <p:nvSpPr>
+          <p:cNvPr id="2" name="Header Placeholder 1"/>
+          <p:cNvSpPr>
+            <a:spLocks noGrp="1"/>
+          </p:cNvSpPr>
+          <p:nvPr>
+            <p:ph type="hdr" sz="quarter"/>
+          </p:nvPr>
+        </p:nvSpPr>
+        <p:spPr>
+          <a:xfrm>
+            <a:off x="0" y="0"/>
+            <a:ext cx="2971800" cy="458788"/>
+          </a:xfrm>
+          <a:prstGeom prst="rect">
+            <a:avLst/>
+          </a:prstGeom>
+        </p:spPr>
+        <p:txBody>
+          <a:bodyPr vert="horz" lIns="91440" tIns="45720" rIns="91440" bIns="45720" rtlCol="0"/>
+          <a:lstStyle>
+            <a:lvl1pPr algn="l">
+              <a:defRPr sz="1200"/>
+            </a:lvl1pPr>
+          </a:lstStyle>
+          <a:p>
+            <a:endParaRPr lang="en-US"/>
+          </a:p>
+        </p:txBody>
+      </p:sp>
+      <p:sp>
+        <p:nvSpPr>
+          <p:cNvPr id="3" name="Date Placeholder 2"/>
+          <p:cNvSpPr>
+            <a:spLocks noGrp="1"/>
+          </p:cNvSpPr>
+          <p:nvPr>
+            <p:ph type="dt" idx="1"/>
+          </p:nvPr>
+        </p:nvSpPr>
+        <p:spPr>
+          <a:xfrm>
+            <a:off x="3884613" y="0"/>
+            <a:ext cx="2971800" cy="458788"/>
+          </a:xfrm>
+          <a:prstGeom prst="rect">
+            <a:avLst/>
+          </a:prstGeom>
+        </p:spPr>
+        <p:txBody>
+          <a:bodyPr vert="horz" lIns="91440" tIns="45720" rIns="91440" bIns="45720" rtlCol="0"/>
+          <a:lstStyle>
+            <a:lvl1pPr algn="r">
+              <a:defRPr sz="1200"/>
+            </a:lvl1pPr>
+          </a:lstStyle>
+          <a:p>
+            <a:fld id="{BCB7D2DC-A857-44B8-BAB7-E101C9C826F2}" type="datetimeFigureOut">
+              <a:rPr lang="en-US" smtClean="0"/>
+              <a:t>2/4/2026</a:t>
+            </a:fld>
+            <a:endParaRPr lang="en-US"/>
+          </a:p>
+        </p:txBody>
+      </p:sp>
+      <p:sp>
+        <p:nvSpPr>
+          <p:cNvPr id="4" name="Slide Image Placeholder 3"/>
+          <p:cNvSpPr>
+            <a:spLocks noGrp="1" noRot="1" noChangeAspect="1"/>
+          </p:cNvSpPr>
+          <p:nvPr>
+            <p:ph type="sldImg" idx="2"/>
+          </p:nvPr>
+        </p:nvSpPr>
+        <p:spPr>
+          <a:xfrm>
+            <a:off x="685800" y="1143000"/>
+            <a:ext cx="5486400" cy="3086100"/>
+          </a:xfrm>
+          <a:prstGeom prst="rect">
+            <a:avLst/>
+          </a:prstGeom>
+          <a:noFill/>
+          <a:ln w="12700">
+            <a:solidFill>
+              <a:prstClr val="black"/>
+            </a:solidFill>
+          </a:ln>
+        </p:spPr>
+        <p:txBody>
+          <a:bodyPr vert="horz" lIns="91440" tIns="45720" rIns="91440" bIns="45720" rtlCol="0" anchor="ctr"/>
+          <a:lstStyle/>
+          <a:p>
+            <a:endParaRPr lang="en-US"/>
+          </a:p>
+        </p:txBody>
+      </p:sp>
+      <p:sp>
+        <p:nvSpPr>
+          <p:cNvPr id="5" name="Notes Placeholder 4"/>
+          <p:cNvSpPr>
+            <a:spLocks noGrp="1"/>
+          </p:cNvSpPr>
+          <p:nvPr>
+            <p:ph type="body" sz="quarter" idx="3"/>
+          </p:nvPr>
+        </p:nvSpPr>
+        <p:spPr>
+          <a:xfrm>
+            <a:off x="685800" y="4400550"/>
+            <a:ext cx="5486400" cy="3600450"/>
+          </a:xfrm>
+          <a:prstGeom prst="rect">
+            <a:avLst/>
+          </a:prstGeom>
+        </p:spPr>
+        <p:txBody>
+          <a:bodyPr vert="horz" lIns="91440" tIns="45720" rIns="91440" bIns="45720" rtlCol="0"/>
+          <a:lstStyle/>
+          <a:p>
+            <a:pPr lvl="0"/>
+            <a:r>
+              <a:rPr lang="en-US"/>
+              <a:t>Click to edit Master text styles</a:t>
+            </a:r>
+          </a:p>
+          <a:p>
+            <a:pPr lvl="1"/>
+            <a:r>
+              <a:rPr lang="en-US"/>
+              <a:t>Second level</a:t>
+            </a:r>
+          </a:p>
+          <a:p>
+            <a:pPr lvl="2"/>
+            <a:r>
+              <a:rPr lang="en-US"/>
+              <a:t>Third level</a:t>
+            </a:r>
+          </a:p>
+          <a:p>
+            <a:pPr lvl="3"/>
+            <a:r>
+              <a:rPr lang="en-US"/>
+              <a:t>Fourth level</a:t>
+            </a:r>
+          </a:p>
+          <a:p>
+            <a:pPr lvl="4"/>
+            <a:r>
+              <a:rPr lang="en-US"/>
+              <a:t>Fifth level</a:t>
+            </a:r>
+          </a:p>
+        </p:txBody>
+      </p:sp>
+      <p:sp>
+        <p:nvSpPr>
+          <p:cNvPr id="6" name="Footer Placeholder 5"/>
+          <p:cNvSpPr>
+            <a:spLocks noGrp="1"/>
+          </p:cNvSpPr>
+          <p:nvPr>
+            <p:ph type="ftr" sz="quarter" idx="4"/>
+          </p:nvPr>
+        </p:nvSpPr>
+        <p:spPr>
+          <a:xfrm>
+            <a:off x="0" y="8685213"/>
+            <a:ext cx="2971800" cy="458787"/>
+          </a:xfrm>
+          <a:prstGeom prst="rect">
+            <a:avLst/>
+          </a:prstGeom>
+        </p:spPr>
+        <p:txBody>
+          <a:bodyPr vert="horz" lIns="91440" tIns="45720" rIns="91440" bIns="45720" rtlCol="0" anchor="b"/>
+          <a:lstStyle>
+            <a:lvl1pPr algn="l">
+              <a:defRPr sz="1200"/>
+            </a:lvl1pPr>
+          </a:lstStyle>
+          <a:p>
+            <a:endParaRPr lang="en-US"/>
+          </a:p>
+        </p:txBody>
+      </p:sp>
+      <p:sp>
+        <p:nvSpPr>
+          <p:cNvPr id="7" name="Slide Number Placeholder 6"/>
+          <p:cNvSpPr>
+            <a:spLocks noGrp="1"/>
+          </p:cNvSpPr>
+          <p:nvPr>
+            <p:ph type="sldNum" sz="quarter" idx="5"/>
+          </p:nvPr>
+        </p:nvSpPr>
+        <p:spPr>
+          <a:xfrm>
+            <a:off x="3884613" y="8685213"/>
+            <a:ext cx="2971800" cy="458787"/>
+          </a:xfrm>
+          <a:prstGeom prst="rect">
+            <a:avLst/>
+          </a:prstGeom>
+        </p:spPr>
+        <p:txBody>
+          <a:bodyPr vert="horz" lIns="91440" tIns="45720" rIns="91440" bIns="45720" rtlCol="0" anchor="b"/>
+          <a:lstStyle>
+            <a:lvl1pPr algn="r">
+              <a:defRPr sz="1200"/>
+            </a:lvl1pPr>
+          </a:lstStyle>
+          <a:p>
+            <a:fld id="{EB1DE26A-896E-45F7-948C-10910CCE1B25}" type="slidenum">
+              <a:rPr lang="en-US" smtClean="0"/>
+              <a:t>‹#›</a:t>
+            </a:fld>
+            <a:endParaRPr lang="en-US"/>
+          </a:p>
+        </p:txBody>
+      </p:sp>
+    </p:spTree>
+    <p:extLst>
+      <p:ext uri="{BB962C8B-B14F-4D97-AF65-F5344CB8AC3E}">
+        <p14:creationId xmlns:p14="http://schemas.microsoft.com/office/powerpoint/2010/main" val="369488296"/>
+      </p:ext>
+    </p:extLst>
+  </p:cSld>
+  <p:clrMap bg1="lt1" tx1="dk1" bg2="lt2" tx2="dk2" accent1="accent1" accent2="accent2" accent3="accent3" accent4="accent4" accent5="accent5" accent6="accent6" hlink="hlink" folHlink="folHlink"/>
+  <p:notesStyle>
+    <a:lvl1pPr marL="0" algn="l" defTabSz="914400" rtl="0" eaLnBrk="1" latinLnBrk="0" hangingPunct="1">
+      <a:defRPr sz="1200" kern="1200">
+        <a:solidFill>
+          <a:schemeClr val="tx1"/>
+        </a:solidFill>
+        <a:latin typeface="+mn-lt"/>
+        <a:ea typeface="+mn-ea"/>
+        <a:cs typeface="+mn-cs"/>
+      </a:defRPr>
+    </a:lvl1pPr>
+    <a:lvl2pPr marL="457200" algn="l" defTabSz="914400" rtl="0" eaLnBrk="1" latinLnBrk="0" hangingPunct="1">
+      <a:defRPr sz="1200" kern="1200">
+        <a:solidFill>
+          <a:schemeClr val="tx1"/>
+        </a:solidFill>
+        <a:latin typeface="+mn-lt"/>
+        <a:ea typeface="+mn-ea"/>
+        <a:cs typeface="+mn-cs"/>
+      </a:defRPr>
+    </a:lvl2pPr>
+    <a:lvl3pPr marL="914400" algn="l" defTabSz="914400" rtl="0" eaLnBrk="1" latinLnBrk="0" hangingPunct="1">
+      <a:defRPr sz="1200" kern="1200">
+        <a:solidFill>
+          <a:schemeClr val="tx1"/>
+        </a:solidFill>
+        <a:latin typeface="+mn-lt"/>
+        <a:ea typeface="+mn-ea"/>
+        <a:cs typeface="+mn-cs"/>
+      </a:defRPr>
+    </a:lvl3pPr>
+    <a:lvl4pPr marL="1371600" algn="l" defTabSz="914400" rtl="0" eaLnBrk="1" latinLnBrk="0" hangingPunct="1">
+      <a:defRPr sz="1200" kern="1200">
+        <a:solidFill>
+          <a:schemeClr val="tx1"/>
+        </a:solidFill>
+        <a:latin typeface="+mn-lt"/>
+        <a:ea typeface="+mn-ea"/>
+        <a:cs typeface="+mn-cs"/>
+      </a:defRPr>
+    </a:lvl4pPr>
+    <a:lvl5pPr marL="1828800" algn="l" defTabSz="914400" rtl="0" eaLnBrk="1" latinLnBrk="0" hangingPunct="1">
+      <a:defRPr sz="1200" kern="1200">
+        <a:solidFill>
+          <a:schemeClr val="tx1"/>
+        </a:solidFill>
+        <a:latin typeface="+mn-lt"/>
+        <a:ea typeface="+mn-ea"/>
+        <a:cs typeface="+mn-cs"/>
+      </a:defRPr>
+    </a:lvl5pPr>
+    <a:lvl6pPr marL="2286000" algn="l" defTabSz="914400" rtl="0" eaLnBrk="1" latinLnBrk="0" hangingPunct="1">
+      <a:defRPr sz="1200" kern="1200">
+        <a:solidFill>
+          <a:schemeClr val="tx1"/>
+        </a:solidFill>
+        <a:latin typeface="+mn-lt"/>
+        <a:ea typeface="+mn-ea"/>
+        <a:cs typeface="+mn-cs"/>
+      </a:defRPr>
+    </a:lvl6pPr>
+    <a:lvl7pPr marL="2743200" algn="l" defTabSz="914400" rtl="0" eaLnBrk="1" latinLnBrk="0" hangingPunct="1">
+      <a:defRPr sz="1200" kern="1200">
+        <a:solidFill>
+          <a:schemeClr val="tx1"/>
+        </a:solidFill>
+        <a:latin typeface="+mn-lt"/>
+        <a:ea typeface="+mn-ea"/>
+        <a:cs typeface="+mn-cs"/>
+      </a:defRPr>
+    </a:lvl7pPr>
+    <a:lvl8pPr marL="3200400" algn="l" defTabSz="914400" rtl="0" eaLnBrk="1" latinLnBrk="0" hangingPunct="1">
+      <a:defRPr sz="1200" kern="1200">
+        <a:solidFill>
+          <a:schemeClr val="tx1"/>
+        </a:solidFill>
+        <a:latin typeface="+mn-lt"/>
+        <a:ea typeface="+mn-ea"/>
+        <a:cs typeface="+mn-cs"/>
+      </a:defRPr>
+    </a:lvl8pPr>
+    <a:lvl9pPr marL="3657600" algn="l" defTabSz="914400" rtl="0" eaLnBrk="1" latinLnBrk="0" hangingPunct="1">
+      <a:defRPr sz="1200" kern="1200">
+        <a:solidFill>
+          <a:schemeClr val="tx1"/>
+        </a:solidFill>
+        <a:latin typeface="+mn-lt"/>
+        <a:ea typeface="+mn-ea"/>
+        <a:cs typeface="+mn-cs"/>
+      </a:defRPr>
+    </a:lvl9pPr>
+  </p:notesStyle>
+</p:notesMaster>
+</file>
+
+<file path=ppt/notesSlides/notesSlide1.xml><?xml version="1.0" encoding="utf-8"?>
+<p:notes xmlns:a="http://schemas.openxmlformats.org/drawingml/2006/main" xmlns:r="http://schemas.openxmlformats.org/officeDocument/2006/relationships" xmlns:p="http://schemas.openxmlformats.org/presentationml/2006/main">
+  <p:cSld>
+    <p:spTree>
+      <p:nvGrpSpPr>
+        <p:cNvPr id="1" name=""/>
+        <p:cNvGrpSpPr/>
+        <p:nvPr/>
+      </p:nvGrpSpPr>
+      <p:grpSpPr>
+        <a:xfrm>
+          <a:off x="0" y="0"/>
+          <a:ext cx="0" cy="0"/>
+          <a:chOff x="0" y="0"/>
+          <a:chExt cx="0" cy="0"/>
+        </a:xfrm>
+      </p:grpSpPr>
+      <p:sp>
+        <p:nvSpPr>
+          <p:cNvPr id="2" name="Slide Image Placeholder 1"/>
+          <p:cNvSpPr>
+            <a:spLocks noGrp="1" noRot="1" noChangeAspect="1"/>
+          </p:cNvSpPr>
+          <p:nvPr>
+            <p:ph type="sldImg"/>
+          </p:nvPr>
+        </p:nvSpPr>
+        <p:spPr/>
+      </p:sp>
+      <p:sp>
+        <p:nvSpPr>
+          <p:cNvPr id="3" name="Notes Placeholder 2"/>
+          <p:cNvSpPr>
+            <a:spLocks noGrp="1"/>
+          </p:cNvSpPr>
+          <p:nvPr>
+            <p:ph type="body" idx="1"/>
+          </p:nvPr>
+        </p:nvSpPr>
+        <p:spPr/>
+        <p:txBody>
+          <a:bodyPr/>
+          <a:lstStyle/>
+          <a:p>
+            <a:pPr marL="171450" indent="-171450">
+              <a:buFontTx/>
+              <a:buChar char="-"/>
+            </a:pPr>
+            <a:r>
+              <a:rPr lang="en-US" dirty="0"/>
+              <a:t>31 healthy adults, one was excluded from RQ3 for 4x high DHEA over assay limit</a:t>
+            </a:r>
+          </a:p>
+          <a:p>
+            <a:pPr marL="171450" indent="-171450">
+              <a:buFontTx/>
+              <a:buChar char="-"/>
+            </a:pPr>
+            <a:r>
+              <a:rPr lang="en-US" dirty="0"/>
+              <a:t>Created new variables for time relating to differences between values</a:t>
+            </a:r>
+          </a:p>
+          <a:p>
+            <a:pPr marL="628650" marR="0" lvl="1" indent="-171450" algn="l" defTabSz="914400" rtl="0" eaLnBrk="1" fontAlgn="auto" latinLnBrk="0" hangingPunct="1">
+              <a:lnSpc>
+                <a:spcPct val="100000"/>
+              </a:lnSpc>
+              <a:spcBef>
+                <a:spcPts val="0"/>
+              </a:spcBef>
+              <a:spcAft>
+                <a:spcPts val="0"/>
+              </a:spcAft>
+              <a:buClrTx/>
+              <a:buSzTx/>
+              <a:buFontTx/>
+              <a:buChar char="-"/>
+              <a:tabLst/>
+              <a:defRPr/>
+            </a:pPr>
+            <a:r>
+              <a:rPr lang="en-US" dirty="0"/>
+              <a:t>Cap times had more missingness than booklet times</a:t>
+            </a:r>
+          </a:p>
+          <a:p>
+            <a:pPr marL="171450" indent="-171450">
+              <a:buFontTx/>
+              <a:buChar char="-"/>
+            </a:pPr>
+            <a:r>
+              <a:rPr lang="en-US" dirty="0"/>
+              <a:t>Cortisol and DHEA had higher values at start than end of day as expected </a:t>
+            </a:r>
+          </a:p>
+        </p:txBody>
+      </p:sp>
+      <p:sp>
+        <p:nvSpPr>
+          <p:cNvPr id="4" name="Slide Number Placeholder 3"/>
+          <p:cNvSpPr>
+            <a:spLocks noGrp="1"/>
+          </p:cNvSpPr>
+          <p:nvPr>
+            <p:ph type="sldNum" sz="quarter" idx="5"/>
+          </p:nvPr>
+        </p:nvSpPr>
+        <p:spPr/>
+        <p:txBody>
+          <a:bodyPr/>
+          <a:lstStyle/>
+          <a:p>
+            <a:fld id="{EB1DE26A-896E-45F7-948C-10910CCE1B25}" type="slidenum">
+              <a:rPr lang="en-US" smtClean="0"/>
+              <a:t>3</a:t>
+            </a:fld>
+            <a:endParaRPr lang="en-US"/>
+          </a:p>
+        </p:txBody>
+      </p:sp>
+    </p:spTree>
+    <p:extLst>
+      <p:ext uri="{BB962C8B-B14F-4D97-AF65-F5344CB8AC3E}">
+        <p14:creationId xmlns:p14="http://schemas.microsoft.com/office/powerpoint/2010/main" val="359375842"/>
+      </p:ext>
+    </p:extLst>
+  </p:cSld>
+  <p:clrMapOvr>
+    <a:masterClrMapping/>
+  </p:clrMapOvr>
+</p:notes>
+</file>
+
+<file path=ppt/notesSlides/notesSlide2.xml><?xml version="1.0" encoding="utf-8"?>
+<p:notes xmlns:a="http://schemas.openxmlformats.org/drawingml/2006/main" xmlns:r="http://schemas.openxmlformats.org/officeDocument/2006/relationships" xmlns:p="http://schemas.openxmlformats.org/presentationml/2006/main">
+  <p:cSld>
+    <p:spTree>
+      <p:nvGrpSpPr>
+        <p:cNvPr id="1" name=""/>
+        <p:cNvGrpSpPr/>
+        <p:nvPr/>
+      </p:nvGrpSpPr>
+      <p:grpSpPr>
+        <a:xfrm>
+          <a:off x="0" y="0"/>
+          <a:ext cx="0" cy="0"/>
+          <a:chOff x="0" y="0"/>
+          <a:chExt cx="0" cy="0"/>
+        </a:xfrm>
+      </p:grpSpPr>
+      <p:sp>
+        <p:nvSpPr>
+          <p:cNvPr id="2" name="Slide Image Placeholder 1"/>
+          <p:cNvSpPr>
+            <a:spLocks noGrp="1" noRot="1" noChangeAspect="1"/>
+          </p:cNvSpPr>
+          <p:nvPr>
+            <p:ph type="sldImg"/>
+          </p:nvPr>
+        </p:nvSpPr>
+        <p:spPr/>
+      </p:sp>
+      <p:sp>
+        <p:nvSpPr>
+          <p:cNvPr id="3" name="Notes Placeholder 2"/>
+          <p:cNvSpPr>
+            <a:spLocks noGrp="1"/>
+          </p:cNvSpPr>
+          <p:nvPr>
+            <p:ph type="body" idx="1"/>
+          </p:nvPr>
+        </p:nvSpPr>
+        <p:spPr/>
+        <p:txBody>
+          <a:bodyPr/>
+          <a:lstStyle/>
+          <a:p>
+            <a:pPr marL="171450" indent="-171450">
+              <a:buFontTx/>
+              <a:buChar char="-"/>
+            </a:pPr>
+            <a:r>
+              <a:rPr lang="en-US" dirty="0"/>
+              <a:t>Booklet and cap times showed a near one‑to‑one relationship (slope = 1)</a:t>
+            </a:r>
+          </a:p>
+          <a:p>
+            <a:pPr marL="171450" indent="-171450">
+              <a:buFontTx/>
+              <a:buChar char="-"/>
+            </a:pPr>
+            <a:r>
+              <a:rPr lang="en-US" dirty="0"/>
+              <a:t>Booklet times were recorded 6.7 minutes earlier on average (intercept != 0)</a:t>
+            </a:r>
+          </a:p>
+          <a:p>
+            <a:pPr marL="171450" indent="-171450">
+              <a:buFontTx/>
+              <a:buChar char="-"/>
+            </a:pPr>
+            <a:r>
+              <a:rPr lang="en-US" dirty="0"/>
+              <a:t>Booklet times were consistently closer to the intended sampling windows than cap times</a:t>
+            </a:r>
+          </a:p>
+          <a:p>
+            <a:pPr marL="171450" indent="-171450">
+              <a:buFontTx/>
+              <a:buChar char="-"/>
+            </a:pPr>
+            <a:r>
+              <a:rPr lang="en-US" dirty="0"/>
+              <a:t>Adherence was lower at the 10‑hour mark, especially for cap times</a:t>
+            </a:r>
+          </a:p>
+          <a:p>
+            <a:endParaRPr lang="en-US" dirty="0"/>
+          </a:p>
+        </p:txBody>
+      </p:sp>
+      <p:sp>
+        <p:nvSpPr>
+          <p:cNvPr id="4" name="Slide Number Placeholder 3"/>
+          <p:cNvSpPr>
+            <a:spLocks noGrp="1"/>
+          </p:cNvSpPr>
+          <p:nvPr>
+            <p:ph type="sldNum" sz="quarter" idx="5"/>
+          </p:nvPr>
+        </p:nvSpPr>
+        <p:spPr/>
+        <p:txBody>
+          <a:bodyPr/>
+          <a:lstStyle/>
+          <a:p>
+            <a:fld id="{EB1DE26A-896E-45F7-948C-10910CCE1B25}" type="slidenum">
+              <a:rPr lang="en-US" smtClean="0"/>
+              <a:t>5</a:t>
+            </a:fld>
+            <a:endParaRPr lang="en-US"/>
+          </a:p>
+        </p:txBody>
+      </p:sp>
+    </p:spTree>
+    <p:extLst>
+      <p:ext uri="{BB962C8B-B14F-4D97-AF65-F5344CB8AC3E}">
+        <p14:creationId xmlns:p14="http://schemas.microsoft.com/office/powerpoint/2010/main" val="358320739"/>
+      </p:ext>
+    </p:extLst>
+  </p:cSld>
+  <p:clrMapOvr>
+    <a:masterClrMapping/>
+  </p:clrMapOvr>
+</p:notes>
+</file>
+
+<file path=ppt/notesSlides/notesSlide3.xml><?xml version="1.0" encoding="utf-8"?>
+<p:notes xmlns:a="http://schemas.openxmlformats.org/drawingml/2006/main" xmlns:r="http://schemas.openxmlformats.org/officeDocument/2006/relationships" xmlns:p="http://schemas.openxmlformats.org/presentationml/2006/main">
+  <p:cSld>
+    <p:spTree>
+      <p:nvGrpSpPr>
+        <p:cNvPr id="1" name=""/>
+        <p:cNvGrpSpPr/>
+        <p:nvPr/>
+      </p:nvGrpSpPr>
+      <p:grpSpPr>
+        <a:xfrm>
+          <a:off x="0" y="0"/>
+          <a:ext cx="0" cy="0"/>
+          <a:chOff x="0" y="0"/>
+          <a:chExt cx="0" cy="0"/>
+        </a:xfrm>
+      </p:grpSpPr>
+      <p:sp>
+        <p:nvSpPr>
+          <p:cNvPr id="2" name="Slide Image Placeholder 1"/>
+          <p:cNvSpPr>
+            <a:spLocks noGrp="1" noRot="1" noChangeAspect="1"/>
+          </p:cNvSpPr>
+          <p:nvPr>
+            <p:ph type="sldImg"/>
+          </p:nvPr>
+        </p:nvSpPr>
+        <p:spPr/>
+      </p:sp>
+      <p:sp>
+        <p:nvSpPr>
+          <p:cNvPr id="3" name="Notes Placeholder 2"/>
+          <p:cNvSpPr>
+            <a:spLocks noGrp="1"/>
+          </p:cNvSpPr>
+          <p:nvPr>
+            <p:ph type="body" idx="1"/>
+          </p:nvPr>
+        </p:nvSpPr>
+        <p:spPr/>
+        <p:txBody>
+          <a:bodyPr/>
+          <a:lstStyle/>
+          <a:p>
+            <a:pPr marL="171450" indent="-171450">
+              <a:buFontTx/>
+              <a:buChar char="-"/>
+            </a:pPr>
+            <a:r>
+              <a:rPr lang="en-US" dirty="0"/>
+              <a:t>Cortisol showed the expected decline after 30 minutes, but the slight rise from wake to 30 minutes wasn’t statistically significant</a:t>
+            </a:r>
+          </a:p>
+          <a:p>
+            <a:pPr marL="171450" indent="-171450">
+              <a:buFontTx/>
+              <a:buChar char="-"/>
+            </a:pPr>
+            <a:r>
+              <a:rPr lang="en-US" dirty="0"/>
+              <a:t>DHEA declined sharply in the first 30 minutes and continued to decline more gradually afterward</a:t>
+            </a:r>
+          </a:p>
+        </p:txBody>
+      </p:sp>
+      <p:sp>
+        <p:nvSpPr>
+          <p:cNvPr id="4" name="Slide Number Placeholder 3"/>
+          <p:cNvSpPr>
+            <a:spLocks noGrp="1"/>
+          </p:cNvSpPr>
+          <p:nvPr>
+            <p:ph type="sldNum" sz="quarter" idx="5"/>
+          </p:nvPr>
+        </p:nvSpPr>
+        <p:spPr/>
+        <p:txBody>
+          <a:bodyPr/>
+          <a:lstStyle/>
+          <a:p>
+            <a:fld id="{EB1DE26A-896E-45F7-948C-10910CCE1B25}" type="slidenum">
+              <a:rPr lang="en-US" smtClean="0"/>
+              <a:t>6</a:t>
+            </a:fld>
+            <a:endParaRPr lang="en-US"/>
+          </a:p>
+        </p:txBody>
+      </p:sp>
+    </p:spTree>
+    <p:extLst>
+      <p:ext uri="{BB962C8B-B14F-4D97-AF65-F5344CB8AC3E}">
+        <p14:creationId xmlns:p14="http://schemas.microsoft.com/office/powerpoint/2010/main" val="747233285"/>
+      </p:ext>
+    </p:extLst>
+  </p:cSld>
+  <p:clrMapOvr>
+    <a:masterClrMapping/>
+  </p:clrMapOvr>
+</p:notes>
+</file>
+
+<file path=ppt/notesSlides/notesSlide4.xml><?xml version="1.0" encoding="utf-8"?>
+<p:notes xmlns:a="http://schemas.openxmlformats.org/drawingml/2006/main" xmlns:r="http://schemas.openxmlformats.org/officeDocument/2006/relationships" xmlns:p="http://schemas.openxmlformats.org/presentationml/2006/main">
+  <p:cSld>
+    <p:spTree>
+      <p:nvGrpSpPr>
+        <p:cNvPr id="1" name=""/>
+        <p:cNvGrpSpPr/>
+        <p:nvPr/>
+      </p:nvGrpSpPr>
+      <p:grpSpPr>
+        <a:xfrm>
+          <a:off x="0" y="0"/>
+          <a:ext cx="0" cy="0"/>
+          <a:chOff x="0" y="0"/>
+          <a:chExt cx="0" cy="0"/>
+        </a:xfrm>
+      </p:grpSpPr>
+      <p:sp>
+        <p:nvSpPr>
+          <p:cNvPr id="2" name="Slide Image Placeholder 1"/>
+          <p:cNvSpPr>
+            <a:spLocks noGrp="1" noRot="1" noChangeAspect="1"/>
+          </p:cNvSpPr>
+          <p:nvPr>
+            <p:ph type="sldImg"/>
+          </p:nvPr>
+        </p:nvSpPr>
+        <p:spPr/>
+      </p:sp>
+      <p:sp>
+        <p:nvSpPr>
+          <p:cNvPr id="3" name="Notes Placeholder 2"/>
+          <p:cNvSpPr>
+            <a:spLocks noGrp="1"/>
+          </p:cNvSpPr>
+          <p:nvPr>
+            <p:ph type="body" idx="1"/>
+          </p:nvPr>
+        </p:nvSpPr>
+        <p:spPr/>
+        <p:txBody>
+          <a:bodyPr/>
+          <a:lstStyle/>
+          <a:p>
+            <a:pPr marL="171450" indent="-171450">
+              <a:buFontTx/>
+              <a:buChar char="-"/>
+            </a:pPr>
+            <a:r>
+              <a:rPr lang="en-US" dirty="0"/>
+              <a:t>No gold‑standard sampling time, making it hard to determine whether discrepancies reflect reporting error, device issues, or participant behavior.</a:t>
+            </a:r>
+          </a:p>
+          <a:p>
+            <a:pPr marL="171450" indent="-171450">
+              <a:buFontTx/>
+              <a:buChar char="-"/>
+            </a:pPr>
+            <a:r>
+              <a:rPr lang="en-US" dirty="0"/>
+              <a:t>Missing and inconsistent cap data, plus small sample size, limit precision and generalizability.</a:t>
+            </a:r>
+          </a:p>
+          <a:p>
+            <a:pPr marL="171450" indent="-171450">
+              <a:buFontTx/>
+              <a:buChar char="-"/>
+            </a:pPr>
+            <a:r>
+              <a:rPr lang="en-US" dirty="0"/>
+              <a:t>Assay and data constraints (e.g., DHEA censoring, excluded participant) may affect hormone trajectory estimates.</a:t>
+            </a:r>
+          </a:p>
+          <a:p>
+            <a:endParaRPr lang="en-US" dirty="0"/>
+          </a:p>
+        </p:txBody>
+      </p:sp>
+      <p:sp>
+        <p:nvSpPr>
+          <p:cNvPr id="4" name="Slide Number Placeholder 3"/>
+          <p:cNvSpPr>
+            <a:spLocks noGrp="1"/>
+          </p:cNvSpPr>
+          <p:nvPr>
+            <p:ph type="sldNum" sz="quarter" idx="5"/>
+          </p:nvPr>
+        </p:nvSpPr>
+        <p:spPr/>
+        <p:txBody>
+          <a:bodyPr/>
+          <a:lstStyle/>
+          <a:p>
+            <a:fld id="{EB1DE26A-896E-45F7-948C-10910CCE1B25}" type="slidenum">
+              <a:rPr lang="en-US" smtClean="0"/>
+              <a:t>7</a:t>
+            </a:fld>
+            <a:endParaRPr lang="en-US"/>
+          </a:p>
+        </p:txBody>
+      </p:sp>
+    </p:spTree>
+    <p:extLst>
+      <p:ext uri="{BB962C8B-B14F-4D97-AF65-F5344CB8AC3E}">
+        <p14:creationId xmlns:p14="http://schemas.microsoft.com/office/powerpoint/2010/main" val="3926037586"/>
+      </p:ext>
+    </p:extLst>
+  </p:cSld>
+  <p:clrMapOvr>
+    <a:masterClrMapping/>
+  </p:clrMapOvr>
+</p:notes>
 </file>
 
 <file path=ppt/slideLayouts/slideLayout1.xml><?xml version="1.0" encoding="utf-8"?>
@@ -298,7 +1312,7 @@
           <a:p>
             <a:fld id="{200DA017-A847-42AB-9875-E393B779F40F}" type="datetimeFigureOut">
               <a:rPr lang="en-US" smtClean="0"/>
-              <a:t>2/3/2026</a:t>
+              <a:t>2/4/2026</a:t>
             </a:fld>
             <a:endParaRPr lang="en-US"/>
           </a:p>
@@ -496,7 +1510,7 @@
           <a:p>
             <a:fld id="{200DA017-A847-42AB-9875-E393B779F40F}" type="datetimeFigureOut">
               <a:rPr lang="en-US" smtClean="0"/>
-              <a:t>2/3/2026</a:t>
+              <a:t>2/4/2026</a:t>
             </a:fld>
             <a:endParaRPr lang="en-US"/>
           </a:p>
@@ -704,7 +1718,7 @@
           <a:p>
             <a:fld id="{200DA017-A847-42AB-9875-E393B779F40F}" type="datetimeFigureOut">
               <a:rPr lang="en-US" smtClean="0"/>
-              <a:t>2/3/2026</a:t>
+              <a:t>2/4/2026</a:t>
             </a:fld>
             <a:endParaRPr lang="en-US"/>
           </a:p>
@@ -902,7 +1916,7 @@
           <a:p>
             <a:fld id="{200DA017-A847-42AB-9875-E393B779F40F}" type="datetimeFigureOut">
               <a:rPr lang="en-US" smtClean="0"/>
-              <a:t>2/3/2026</a:t>
+              <a:t>2/4/2026</a:t>
             </a:fld>
             <a:endParaRPr lang="en-US"/>
           </a:p>
@@ -1177,7 +2191,7 @@
           <a:p>
             <a:fld id="{200DA017-A847-42AB-9875-E393B779F40F}" type="datetimeFigureOut">
               <a:rPr lang="en-US" smtClean="0"/>
-              <a:t>2/3/2026</a:t>
+              <a:t>2/4/2026</a:t>
             </a:fld>
             <a:endParaRPr lang="en-US"/>
           </a:p>
@@ -1442,7 +2456,7 @@
           <a:p>
             <a:fld id="{200DA017-A847-42AB-9875-E393B779F40F}" type="datetimeFigureOut">
               <a:rPr lang="en-US" smtClean="0"/>
-              <a:t>2/3/2026</a:t>
+              <a:t>2/4/2026</a:t>
             </a:fld>
             <a:endParaRPr lang="en-US"/>
           </a:p>
@@ -1854,7 +2868,7 @@
           <a:p>
             <a:fld id="{200DA017-A847-42AB-9875-E393B779F40F}" type="datetimeFigureOut">
               <a:rPr lang="en-US" smtClean="0"/>
-              <a:t>2/3/2026</a:t>
+              <a:t>2/4/2026</a:t>
             </a:fld>
             <a:endParaRPr lang="en-US"/>
           </a:p>
@@ -1995,7 +3009,7 @@
           <a:p>
             <a:fld id="{200DA017-A847-42AB-9875-E393B779F40F}" type="datetimeFigureOut">
               <a:rPr lang="en-US" smtClean="0"/>
-              <a:t>2/3/2026</a:t>
+              <a:t>2/4/2026</a:t>
             </a:fld>
             <a:endParaRPr lang="en-US"/>
           </a:p>
@@ -2108,7 +3122,7 @@
           <a:p>
             <a:fld id="{200DA017-A847-42AB-9875-E393B779F40F}" type="datetimeFigureOut">
               <a:rPr lang="en-US" smtClean="0"/>
-              <a:t>2/3/2026</a:t>
+              <a:t>2/4/2026</a:t>
             </a:fld>
             <a:endParaRPr lang="en-US"/>
           </a:p>
@@ -2419,7 +3433,7 @@
           <a:p>
             <a:fld id="{200DA017-A847-42AB-9875-E393B779F40F}" type="datetimeFigureOut">
               <a:rPr lang="en-US" smtClean="0"/>
-              <a:t>2/3/2026</a:t>
+              <a:t>2/4/2026</a:t>
             </a:fld>
             <a:endParaRPr lang="en-US"/>
           </a:p>
@@ -2707,7 +3721,7 @@
           <a:p>
             <a:fld id="{200DA017-A847-42AB-9875-E393B779F40F}" type="datetimeFigureOut">
               <a:rPr lang="en-US" smtClean="0"/>
-              <a:t>2/3/2026</a:t>
+              <a:t>2/4/2026</a:t>
             </a:fld>
             <a:endParaRPr lang="en-US"/>
           </a:p>
@@ -2948,7 +3962,7 @@
           <a:p>
             <a:fld id="{200DA017-A847-42AB-9875-E393B779F40F}" type="datetimeFigureOut">
               <a:rPr lang="en-US" smtClean="0"/>
-              <a:t>2/3/2026</a:t>
+              <a:t>2/4/2026</a:t>
             </a:fld>
             <a:endParaRPr lang="en-US"/>
           </a:p>
@@ -3383,12 +4397,14 @@
         </p:nvSpPr>
         <p:spPr/>
         <p:txBody>
-          <a:bodyPr/>
+          <a:bodyPr>
+            <a:normAutofit fontScale="90000"/>
+          </a:bodyPr>
           <a:lstStyle/>
           <a:p>
             <a:r>
               <a:rPr lang="en-US" dirty="0"/>
-              <a:t>P0 Presentation</a:t>
+              <a:t>Timing, Adherence, and Hormone Profiles in a Novel Saliva Device</a:t>
             </a:r>
           </a:p>
         </p:txBody>
@@ -3413,10 +4429,22 @@
         <p:txBody>
           <a:bodyPr/>
           <a:lstStyle/>
+          <a:p>
+            <a:r>
+              <a:rPr lang="en-US" dirty="0"/>
+              <a:t>Project 0</a:t>
+            </a:r>
+          </a:p>
           <a:p>
             <a:r>
               <a:rPr lang="en-US" dirty="0"/>
               <a:t>Ezra Weible</a:t>
+            </a:r>
+          </a:p>
+          <a:p>
+            <a:r>
+              <a:rPr lang="en-US" dirty="0"/>
+              <a:t>4 February 2026</a:t>
             </a:r>
           </a:p>
         </p:txBody>
@@ -3500,28 +4528,31 @@
           <a:bodyPr/>
           <a:lstStyle/>
           <a:p>
+            <a:pPr marL="514350" indent="-514350">
+              <a:buAutoNum type="arabicParenR"/>
+            </a:pPr>
             <a:r>
               <a:rPr lang="en-US" dirty="0"/>
-              <a:t>RQ1:</a:t>
-            </a:r>
-          </a:p>
-          <a:p>
+              <a:t>How closely do the booklet reported sampling times agree with electronic cap times?</a:t>
+            </a:r>
+          </a:p>
+          <a:p>
+            <a:pPr marL="514350" indent="-514350">
+              <a:buAutoNum type="arabicParenR"/>
+            </a:pPr>
             <a:r>
               <a:rPr lang="en-US" dirty="0"/>
-              <a:t>RQ2:</a:t>
-            </a:r>
-          </a:p>
-          <a:p>
+              <a:t>Do participants adhere to the 30 minute and 10 hour sampling times required by a study protocol?</a:t>
+            </a:r>
+          </a:p>
+          <a:p>
+            <a:pPr marL="514350" indent="-514350">
+              <a:buAutoNum type="arabicParenR"/>
+            </a:pPr>
             <a:r>
               <a:rPr lang="en-US" dirty="0"/>
-              <a:t>RQ3:</a:t>
-            </a:r>
-          </a:p>
-          <a:p>
-            <a:pPr marL="0" indent="0">
-              <a:buNone/>
-            </a:pPr>
-            <a:endParaRPr lang="en-US" dirty="0"/>
+              <a:t>How cortisol and DHEA change from wake to 30 minutes and from 30 minutes to 10 hours? </a:t>
+            </a:r>
           </a:p>
         </p:txBody>
       </p:sp>
@@ -3583,34 +4614,36 @@
           </a:p>
         </p:txBody>
       </p:sp>
-      <p:sp>
-        <p:nvSpPr>
-          <p:cNvPr id="3" name="Content Placeholder 2">
-            <a:extLst>
-              <a:ext uri="{FF2B5EF4-FFF2-40B4-BE49-F238E27FC236}">
-                <a16:creationId xmlns:a16="http://schemas.microsoft.com/office/drawing/2014/main" id="{FAFA35C1-F2C2-D64A-2CD8-A011B864D209}"/>
-              </a:ext>
-            </a:extLst>
-          </p:cNvPr>
-          <p:cNvSpPr>
-            <a:spLocks noGrp="1"/>
-          </p:cNvSpPr>
-          <p:nvPr>
-            <p:ph idx="1"/>
-          </p:nvPr>
-        </p:nvSpPr>
-        <p:spPr/>
-        <p:txBody>
-          <a:bodyPr/>
-          <a:lstStyle/>
-          <a:p>
-            <a:r>
-              <a:rPr lang="en-US" dirty="0"/>
-              <a:t>Insert Table 1 here</a:t>
-            </a:r>
-          </a:p>
-        </p:txBody>
-      </p:sp>
+      <p:pic>
+        <p:nvPicPr>
+          <p:cNvPr id="5" name="Picture 4">
+            <a:extLst>
+              <a:ext uri="{FF2B5EF4-FFF2-40B4-BE49-F238E27FC236}">
+                <a16:creationId xmlns:a16="http://schemas.microsoft.com/office/drawing/2014/main" id="{B290F37E-41C6-B65E-54A3-38BFA37970FF}"/>
+              </a:ext>
+            </a:extLst>
+          </p:cNvPr>
+          <p:cNvPicPr>
+            <a:picLocks noChangeAspect="1"/>
+          </p:cNvPicPr>
+          <p:nvPr/>
+        </p:nvPicPr>
+        <p:blipFill>
+          <a:blip r:embed="rId3"/>
+          <a:stretch>
+            <a:fillRect/>
+          </a:stretch>
+        </p:blipFill>
+        <p:spPr>
+          <a:xfrm>
+            <a:off x="855628" y="1690688"/>
+            <a:ext cx="10498172" cy="4367944"/>
+          </a:xfrm>
+          <a:prstGeom prst="rect">
+            <a:avLst/>
+          </a:prstGeom>
+        </p:spPr>
+      </p:pic>
     </p:spTree>
     <p:extLst>
       <p:ext uri="{BB962C8B-B14F-4D97-AF65-F5344CB8AC3E}">
@@ -3690,42 +4723,38 @@
           <a:bodyPr/>
           <a:lstStyle/>
           <a:p>
+            <a:pPr marL="514350" indent="-514350">
+              <a:buAutoNum type="arabicParenR"/>
+            </a:pPr>
             <a:r>
               <a:rPr lang="en-US" dirty="0"/>
-              <a:t>RQ1:</a:t>
-            </a:r>
-          </a:p>
-          <a:p>
-            <a:pPr lvl="1"/>
+              <a:t>LMM testing perfect agreement between booklet and cap times</a:t>
+            </a:r>
+          </a:p>
+          <a:p>
+            <a:pPr marL="514350" indent="-514350">
+              <a:buAutoNum type="arabicParenR"/>
+            </a:pPr>
             <a:r>
               <a:rPr lang="en-US" dirty="0"/>
-              <a:t>LMM </a:t>
-            </a:r>
-          </a:p>
-          <a:p>
+              <a:t>Adherence summaries (±7.5 min, ±15 min) at 30 min and 10 </a:t>
+            </a:r>
+            <a:r>
+              <a:rPr lang="en-US" dirty="0" err="1"/>
+              <a:t>hr</a:t>
+            </a:r>
             <a:r>
               <a:rPr lang="en-US" dirty="0"/>
-              <a:t>RQ2:</a:t>
-            </a:r>
-          </a:p>
-          <a:p>
-            <a:pPr lvl="1"/>
+              <a:t> targets</a:t>
+            </a:r>
+          </a:p>
+          <a:p>
+            <a:pPr marL="514350" indent="-514350">
+              <a:buAutoNum type="arabicParenR"/>
+            </a:pPr>
             <a:r>
               <a:rPr lang="en-US" dirty="0"/>
-              <a:t>Descriptive Statistics</a:t>
-            </a:r>
-          </a:p>
-          <a:p>
-            <a:r>
-              <a:rPr lang="en-US" dirty="0"/>
-              <a:t>RQ3:	</a:t>
-            </a:r>
-          </a:p>
-          <a:p>
-            <a:pPr lvl="1"/>
-            <a:r>
-              <a:rPr lang="en-US" dirty="0"/>
-              <a:t>Piecewise LMM</a:t>
+              <a:t>Piecewise LMM for log-transformed cortisol and DHEA (knot at 30 min)</a:t>
             </a:r>
           </a:p>
         </p:txBody>
@@ -3776,14 +4805,19 @@
             <p:ph type="title"/>
           </p:nvPr>
         </p:nvSpPr>
-        <p:spPr/>
+        <p:spPr>
+          <a:xfrm>
+            <a:off x="838200" y="156578"/>
+            <a:ext cx="10515600" cy="1325563"/>
+          </a:xfrm>
+        </p:spPr>
         <p:txBody>
           <a:bodyPr/>
           <a:lstStyle/>
           <a:p>
             <a:r>
               <a:rPr lang="en-US" dirty="0"/>
-              <a:t>Results</a:t>
+              <a:t>Results – RQ1 and RQ2</a:t>
             </a:r>
           </a:p>
         </p:txBody>
@@ -3828,7 +4862,7 @@
           <p:nvPr/>
         </p:nvPicPr>
         <p:blipFill>
-          <a:blip r:embed="rId2"/>
+          <a:blip r:embed="rId3"/>
           <a:srcRect l="1309" t="1257" r="1063" b="2331"/>
           <a:stretch>
             <a:fillRect/>
@@ -3836,8 +4870,8 @@
         </p:blipFill>
         <p:spPr>
           <a:xfrm>
-            <a:off x="482321" y="2106852"/>
-            <a:ext cx="7154426" cy="4386023"/>
+            <a:off x="-1" y="1144589"/>
+            <a:ext cx="9319645" cy="5713411"/>
           </a:xfrm>
           <a:prstGeom prst="rect">
             <a:avLst/>
@@ -3859,15 +4893,15 @@
           <p:nvPr/>
         </p:nvPicPr>
         <p:blipFill>
-          <a:blip r:embed="rId3"/>
+          <a:blip r:embed="rId4"/>
           <a:stretch>
             <a:fillRect/>
           </a:stretch>
         </p:blipFill>
         <p:spPr>
           <a:xfrm>
-            <a:off x="4059534" y="1027906"/>
-            <a:ext cx="6630325" cy="4105848"/>
+            <a:off x="2965701" y="1144589"/>
+            <a:ext cx="9226299" cy="5713412"/>
           </a:xfrm>
           <a:prstGeom prst="rect">
             <a:avLst/>
@@ -3884,6 +4918,153 @@
   <p:clrMapOvr>
     <a:masterClrMapping/>
   </p:clrMapOvr>
+  <p:timing>
+    <p:tnLst>
+      <p:par>
+        <p:cTn id="1" dur="indefinite" restart="never" nodeType="tmRoot">
+          <p:childTnLst>
+            <p:seq concurrent="1" nextAc="seek">
+              <p:cTn id="2" dur="indefinite" nodeType="mainSeq">
+                <p:childTnLst>
+                  <p:par>
+                    <p:cTn id="3" fill="hold">
+                      <p:stCondLst>
+                        <p:cond delay="indefinite"/>
+                      </p:stCondLst>
+                      <p:childTnLst>
+                        <p:par>
+                          <p:cTn id="4" fill="hold">
+                            <p:stCondLst>
+                              <p:cond delay="0"/>
+                            </p:stCondLst>
+                            <p:childTnLst>
+                              <p:par>
+                                <p:cTn id="5" presetID="1" presetClass="entr" presetSubtype="0" fill="hold" nodeType="clickEffect">
+                                  <p:stCondLst>
+                                    <p:cond delay="0"/>
+                                  </p:stCondLst>
+                                  <p:childTnLst>
+                                    <p:set>
+                                      <p:cBhvr>
+                                        <p:cTn id="6" dur="1" fill="hold">
+                                          <p:stCondLst>
+                                            <p:cond delay="0"/>
+                                          </p:stCondLst>
+                                        </p:cTn>
+                                        <p:tgtEl>
+                                          <p:spTgt spid="5"/>
+                                        </p:tgtEl>
+                                        <p:attrNameLst>
+                                          <p:attrName>style.visibility</p:attrName>
+                                        </p:attrNameLst>
+                                      </p:cBhvr>
+                                      <p:to>
+                                        <p:strVal val="visible"/>
+                                      </p:to>
+                                    </p:set>
+                                  </p:childTnLst>
+                                </p:cTn>
+                              </p:par>
+                            </p:childTnLst>
+                          </p:cTn>
+                        </p:par>
+                      </p:childTnLst>
+                    </p:cTn>
+                  </p:par>
+                  <p:par>
+                    <p:cTn id="7" fill="hold">
+                      <p:stCondLst>
+                        <p:cond delay="indefinite"/>
+                      </p:stCondLst>
+                      <p:childTnLst>
+                        <p:par>
+                          <p:cTn id="8" fill="hold">
+                            <p:stCondLst>
+                              <p:cond delay="0"/>
+                            </p:stCondLst>
+                            <p:childTnLst>
+                              <p:par>
+                                <p:cTn id="9" presetID="1" presetClass="entr" presetSubtype="0" fill="hold" nodeType="clickEffect">
+                                  <p:stCondLst>
+                                    <p:cond delay="0"/>
+                                  </p:stCondLst>
+                                  <p:childTnLst>
+                                    <p:set>
+                                      <p:cBhvr>
+                                        <p:cTn id="10" dur="1" fill="hold">
+                                          <p:stCondLst>
+                                            <p:cond delay="0"/>
+                                          </p:stCondLst>
+                                        </p:cTn>
+                                        <p:tgtEl>
+                                          <p:spTgt spid="7"/>
+                                        </p:tgtEl>
+                                        <p:attrNameLst>
+                                          <p:attrName>style.visibility</p:attrName>
+                                        </p:attrNameLst>
+                                      </p:cBhvr>
+                                      <p:to>
+                                        <p:strVal val="visible"/>
+                                      </p:to>
+                                    </p:set>
+                                  </p:childTnLst>
+                                </p:cTn>
+                              </p:par>
+                              <p:par>
+                                <p:cTn id="11" presetID="1" presetClass="exit" presetSubtype="0" fill="hold" nodeType="withEffect">
+                                  <p:stCondLst>
+                                    <p:cond delay="0"/>
+                                  </p:stCondLst>
+                                  <p:childTnLst>
+                                    <p:set>
+                                      <p:cBhvr>
+                                        <p:cTn id="12" dur="1" fill="hold">
+                                          <p:stCondLst>
+                                            <p:cond delay="0"/>
+                                          </p:stCondLst>
+                                        </p:cTn>
+                                        <p:tgtEl>
+                                          <p:spTgt spid="5"/>
+                                        </p:tgtEl>
+                                        <p:attrNameLst>
+                                          <p:attrName>style.visibility</p:attrName>
+                                        </p:attrNameLst>
+                                      </p:cBhvr>
+                                      <p:to>
+                                        <p:strVal val="hidden"/>
+                                      </p:to>
+                                    </p:set>
+                                  </p:childTnLst>
+                                </p:cTn>
+                              </p:par>
+                            </p:childTnLst>
+                          </p:cTn>
+                        </p:par>
+                      </p:childTnLst>
+                    </p:cTn>
+                  </p:par>
+                </p:childTnLst>
+              </p:cTn>
+              <p:prevCondLst>
+                <p:cond evt="onPrev" delay="0">
+                  <p:tgtEl>
+                    <p:sldTgt/>
+                  </p:tgtEl>
+                </p:cond>
+              </p:prevCondLst>
+              <p:nextCondLst>
+                <p:cond evt="onNext" delay="0">
+                  <p:tgtEl>
+                    <p:sldTgt/>
+                  </p:tgtEl>
+                </p:cond>
+              </p:nextCondLst>
+            </p:seq>
+          </p:childTnLst>
+        </p:cTn>
+      </p:par>
+    </p:tnLst>
+  </p:timing>
 </p:sld>
 </file>
 
@@ -3906,34 +5087,6 @@
       </p:grpSpPr>
       <p:sp>
         <p:nvSpPr>
-          <p:cNvPr id="2" name="Title 1">
-            <a:extLst>
-              <a:ext uri="{FF2B5EF4-FFF2-40B4-BE49-F238E27FC236}">
-                <a16:creationId xmlns:a16="http://schemas.microsoft.com/office/drawing/2014/main" id="{2A1B6C7D-E0EE-8D12-D0CC-F7E8C8E796E0}"/>
-              </a:ext>
-            </a:extLst>
-          </p:cNvPr>
-          <p:cNvSpPr>
-            <a:spLocks noGrp="1"/>
-          </p:cNvSpPr>
-          <p:nvPr>
-            <p:ph type="title"/>
-          </p:nvPr>
-        </p:nvSpPr>
-        <p:spPr/>
-        <p:txBody>
-          <a:bodyPr/>
-          <a:lstStyle/>
-          <a:p>
-            <a:r>
-              <a:rPr lang="en-US" dirty="0"/>
-              <a:t>Results</a:t>
-            </a:r>
-          </a:p>
-        </p:txBody>
-      </p:sp>
-      <p:sp>
-        <p:nvSpPr>
           <p:cNvPr id="3" name="Content Placeholder 2">
             <a:extLst>
               <a:ext uri="{FF2B5EF4-FFF2-40B4-BE49-F238E27FC236}">
@@ -3963,36 +5116,6 @@
             <a:extLst>
               <a:ext uri="{FF2B5EF4-FFF2-40B4-BE49-F238E27FC236}">
                 <a16:creationId xmlns:a16="http://schemas.microsoft.com/office/drawing/2014/main" id="{CAAAF50B-0476-6BF4-C727-6F9FC8380B2D}"/>
-              </a:ext>
-            </a:extLst>
-          </p:cNvPr>
-          <p:cNvPicPr>
-            <a:picLocks noChangeAspect="1"/>
-          </p:cNvPicPr>
-          <p:nvPr/>
-        </p:nvPicPr>
-        <p:blipFill>
-          <a:blip r:embed="rId2"/>
-          <a:stretch>
-            <a:fillRect/>
-          </a:stretch>
-        </p:blipFill>
-        <p:spPr>
-          <a:xfrm>
-            <a:off x="0" y="1825624"/>
-            <a:ext cx="6620799" cy="4067743"/>
-          </a:xfrm>
-          <a:prstGeom prst="rect">
-            <a:avLst/>
-          </a:prstGeom>
-        </p:spPr>
-      </p:pic>
-      <p:pic>
-        <p:nvPicPr>
-          <p:cNvPr id="7" name="Picture 6">
-            <a:extLst>
-              <a:ext uri="{FF2B5EF4-FFF2-40B4-BE49-F238E27FC236}">
-                <a16:creationId xmlns:a16="http://schemas.microsoft.com/office/drawing/2014/main" id="{ACB4619F-0CAC-029A-C14B-D280A67E37B5}"/>
               </a:ext>
             </a:extLst>
           </p:cNvPr>
@@ -4009,14 +5132,77 @@
         </p:blipFill>
         <p:spPr>
           <a:xfrm>
-            <a:off x="5580727" y="1962659"/>
-            <a:ext cx="6611273" cy="4077269"/>
+            <a:off x="0" y="1482141"/>
+            <a:ext cx="8749934" cy="5375859"/>
           </a:xfrm>
           <a:prstGeom prst="rect">
             <a:avLst/>
           </a:prstGeom>
         </p:spPr>
       </p:pic>
+      <p:pic>
+        <p:nvPicPr>
+          <p:cNvPr id="7" name="Picture 6">
+            <a:extLst>
+              <a:ext uri="{FF2B5EF4-FFF2-40B4-BE49-F238E27FC236}">
+                <a16:creationId xmlns:a16="http://schemas.microsoft.com/office/drawing/2014/main" id="{ACB4619F-0CAC-029A-C14B-D280A67E37B5}"/>
+              </a:ext>
+            </a:extLst>
+          </p:cNvPr>
+          <p:cNvPicPr>
+            <a:picLocks noChangeAspect="1"/>
+          </p:cNvPicPr>
+          <p:nvPr/>
+        </p:nvPicPr>
+        <p:blipFill>
+          <a:blip r:embed="rId4"/>
+          <a:stretch>
+            <a:fillRect/>
+          </a:stretch>
+        </p:blipFill>
+        <p:spPr>
+          <a:xfrm>
+            <a:off x="3475069" y="1482141"/>
+            <a:ext cx="8716931" cy="5375859"/>
+          </a:xfrm>
+          <a:prstGeom prst="rect">
+            <a:avLst/>
+          </a:prstGeom>
+        </p:spPr>
+      </p:pic>
+      <p:sp>
+        <p:nvSpPr>
+          <p:cNvPr id="9" name="Title 1">
+            <a:extLst>
+              <a:ext uri="{FF2B5EF4-FFF2-40B4-BE49-F238E27FC236}">
+                <a16:creationId xmlns:a16="http://schemas.microsoft.com/office/drawing/2014/main" id="{B56850CE-A908-F6A5-B025-26C864342C30}"/>
+              </a:ext>
+            </a:extLst>
+          </p:cNvPr>
+          <p:cNvSpPr>
+            <a:spLocks noGrp="1"/>
+          </p:cNvSpPr>
+          <p:nvPr>
+            <p:ph type="title"/>
+          </p:nvPr>
+        </p:nvSpPr>
+        <p:spPr>
+          <a:xfrm>
+            <a:off x="838200" y="156578"/>
+            <a:ext cx="10515600" cy="1325563"/>
+          </a:xfrm>
+        </p:spPr>
+        <p:txBody>
+          <a:bodyPr/>
+          <a:lstStyle/>
+          <a:p>
+            <a:r>
+              <a:rPr lang="en-US" dirty="0"/>
+              <a:t>Results – RQ3</a:t>
+            </a:r>
+          </a:p>
+        </p:txBody>
+      </p:sp>
     </p:spTree>
     <p:extLst>
       <p:ext uri="{BB962C8B-B14F-4D97-AF65-F5344CB8AC3E}">
@@ -4027,6 +5213,153 @@
   <p:clrMapOvr>
     <a:masterClrMapping/>
   </p:clrMapOvr>
+  <p:timing>
+    <p:tnLst>
+      <p:par>
+        <p:cTn id="1" dur="indefinite" restart="never" nodeType="tmRoot">
+          <p:childTnLst>
+            <p:seq concurrent="1" nextAc="seek">
+              <p:cTn id="2" dur="indefinite" nodeType="mainSeq">
+                <p:childTnLst>
+                  <p:par>
+                    <p:cTn id="3" fill="hold">
+                      <p:stCondLst>
+                        <p:cond delay="indefinite"/>
+                      </p:stCondLst>
+                      <p:childTnLst>
+                        <p:par>
+                          <p:cTn id="4" fill="hold">
+                            <p:stCondLst>
+                              <p:cond delay="0"/>
+                            </p:stCondLst>
+                            <p:childTnLst>
+                              <p:par>
+                                <p:cTn id="5" presetID="1" presetClass="entr" presetSubtype="0" fill="hold" nodeType="clickEffect">
+                                  <p:stCondLst>
+                                    <p:cond delay="0"/>
+                                  </p:stCondLst>
+                                  <p:childTnLst>
+                                    <p:set>
+                                      <p:cBhvr>
+                                        <p:cTn id="6" dur="1" fill="hold">
+                                          <p:stCondLst>
+                                            <p:cond delay="0"/>
+                                          </p:stCondLst>
+                                        </p:cTn>
+                                        <p:tgtEl>
+                                          <p:spTgt spid="5"/>
+                                        </p:tgtEl>
+                                        <p:attrNameLst>
+                                          <p:attrName>style.visibility</p:attrName>
+                                        </p:attrNameLst>
+                                      </p:cBhvr>
+                                      <p:to>
+                                        <p:strVal val="visible"/>
+                                      </p:to>
+                                    </p:set>
+                                  </p:childTnLst>
+                                </p:cTn>
+                              </p:par>
+                            </p:childTnLst>
+                          </p:cTn>
+                        </p:par>
+                      </p:childTnLst>
+                    </p:cTn>
+                  </p:par>
+                  <p:par>
+                    <p:cTn id="7" fill="hold">
+                      <p:stCondLst>
+                        <p:cond delay="indefinite"/>
+                      </p:stCondLst>
+                      <p:childTnLst>
+                        <p:par>
+                          <p:cTn id="8" fill="hold">
+                            <p:stCondLst>
+                              <p:cond delay="0"/>
+                            </p:stCondLst>
+                            <p:childTnLst>
+                              <p:par>
+                                <p:cTn id="9" presetID="1" presetClass="entr" presetSubtype="0" fill="hold" nodeType="clickEffect">
+                                  <p:stCondLst>
+                                    <p:cond delay="0"/>
+                                  </p:stCondLst>
+                                  <p:childTnLst>
+                                    <p:set>
+                                      <p:cBhvr>
+                                        <p:cTn id="10" dur="1" fill="hold">
+                                          <p:stCondLst>
+                                            <p:cond delay="0"/>
+                                          </p:stCondLst>
+                                        </p:cTn>
+                                        <p:tgtEl>
+                                          <p:spTgt spid="7"/>
+                                        </p:tgtEl>
+                                        <p:attrNameLst>
+                                          <p:attrName>style.visibility</p:attrName>
+                                        </p:attrNameLst>
+                                      </p:cBhvr>
+                                      <p:to>
+                                        <p:strVal val="visible"/>
+                                      </p:to>
+                                    </p:set>
+                                  </p:childTnLst>
+                                </p:cTn>
+                              </p:par>
+                              <p:par>
+                                <p:cTn id="11" presetID="1" presetClass="exit" presetSubtype="0" fill="hold" nodeType="withEffect">
+                                  <p:stCondLst>
+                                    <p:cond delay="0"/>
+                                  </p:stCondLst>
+                                  <p:childTnLst>
+                                    <p:set>
+                                      <p:cBhvr>
+                                        <p:cTn id="12" dur="1" fill="hold">
+                                          <p:stCondLst>
+                                            <p:cond delay="0"/>
+                                          </p:stCondLst>
+                                        </p:cTn>
+                                        <p:tgtEl>
+                                          <p:spTgt spid="5"/>
+                                        </p:tgtEl>
+                                        <p:attrNameLst>
+                                          <p:attrName>style.visibility</p:attrName>
+                                        </p:attrNameLst>
+                                      </p:cBhvr>
+                                      <p:to>
+                                        <p:strVal val="hidden"/>
+                                      </p:to>
+                                    </p:set>
+                                  </p:childTnLst>
+                                </p:cTn>
+                              </p:par>
+                            </p:childTnLst>
+                          </p:cTn>
+                        </p:par>
+                      </p:childTnLst>
+                    </p:cTn>
+                  </p:par>
+                </p:childTnLst>
+              </p:cTn>
+              <p:prevCondLst>
+                <p:cond evt="onPrev" delay="0">
+                  <p:tgtEl>
+                    <p:sldTgt/>
+                  </p:tgtEl>
+                </p:cond>
+              </p:prevCondLst>
+              <p:nextCondLst>
+                <p:cond evt="onNext" delay="0">
+                  <p:tgtEl>
+                    <p:sldTgt/>
+                  </p:tgtEl>
+                </p:cond>
+              </p:nextCondLst>
+            </p:seq>
+          </p:childTnLst>
+        </p:cTn>
+      </p:par>
+    </p:tnLst>
+  </p:timing>
 </p:sld>
 </file>
 
@@ -4070,7 +5403,7 @@
           <a:p>
             <a:r>
               <a:rPr lang="en-US" dirty="0"/>
-              <a:t>Discussion</a:t>
+              <a:t>Discussion - Limitations</a:t>
             </a:r>
           </a:p>
         </p:txBody>
@@ -4096,7 +5429,22 @@
           <a:bodyPr/>
           <a:lstStyle/>
           <a:p>
-            <a:endParaRPr lang="en-US" dirty="0"/>
+            <a:r>
+              <a:rPr lang="en-US" dirty="0"/>
+              <a:t>No gold‑standard sampling time</a:t>
+            </a:r>
+          </a:p>
+          <a:p>
+            <a:r>
+              <a:rPr lang="en-US" dirty="0"/>
+              <a:t>Missing and inconsistent cap data</a:t>
+            </a:r>
+          </a:p>
+          <a:p>
+            <a:r>
+              <a:rPr lang="en-US" dirty="0"/>
+              <a:t>Assay and data constraints</a:t>
+            </a:r>
           </a:p>
         </p:txBody>
       </p:sp>
@@ -4104,89 +5452,6 @@
     <p:extLst>
       <p:ext uri="{BB962C8B-B14F-4D97-AF65-F5344CB8AC3E}">
         <p14:creationId xmlns:p14="http://schemas.microsoft.com/office/powerpoint/2010/main" val="303442114"/>
-      </p:ext>
-    </p:extLst>
-  </p:cSld>
-  <p:clrMapOvr>
-    <a:masterClrMapping/>
-  </p:clrMapOvr>
-</p:sld>
-</file>
-
-<file path=ppt/slides/slide8.xml><?xml version="1.0" encoding="utf-8"?>
-<p:sld xmlns:a="http://schemas.openxmlformats.org/drawingml/2006/main" xmlns:r="http://schemas.openxmlformats.org/officeDocument/2006/relationships" xmlns:p="http://schemas.openxmlformats.org/presentationml/2006/main">
-  <p:cSld>
-    <p:spTree>
-      <p:nvGrpSpPr>
-        <p:cNvPr id="1" name=""/>
-        <p:cNvGrpSpPr/>
-        <p:nvPr/>
-      </p:nvGrpSpPr>
-      <p:grpSpPr>
-        <a:xfrm>
-          <a:off x="0" y="0"/>
-          <a:ext cx="0" cy="0"/>
-          <a:chOff x="0" y="0"/>
-          <a:chExt cx="0" cy="0"/>
-        </a:xfrm>
-      </p:grpSpPr>
-      <p:sp>
-        <p:nvSpPr>
-          <p:cNvPr id="2" name="Title 1">
-            <a:extLst>
-              <a:ext uri="{FF2B5EF4-FFF2-40B4-BE49-F238E27FC236}">
-                <a16:creationId xmlns:a16="http://schemas.microsoft.com/office/drawing/2014/main" id="{4CE76D85-8EC2-BC15-3AD0-E71A2C1F020B}"/>
-              </a:ext>
-            </a:extLst>
-          </p:cNvPr>
-          <p:cNvSpPr>
-            <a:spLocks noGrp="1"/>
-          </p:cNvSpPr>
-          <p:nvPr>
-            <p:ph type="title"/>
-          </p:nvPr>
-        </p:nvSpPr>
-        <p:spPr/>
-        <p:txBody>
-          <a:bodyPr/>
-          <a:lstStyle/>
-          <a:p>
-            <a:r>
-              <a:rPr lang="en-US" dirty="0"/>
-              <a:t>Questions?</a:t>
-            </a:r>
-          </a:p>
-        </p:txBody>
-      </p:sp>
-      <p:sp>
-        <p:nvSpPr>
-          <p:cNvPr id="3" name="Content Placeholder 2">
-            <a:extLst>
-              <a:ext uri="{FF2B5EF4-FFF2-40B4-BE49-F238E27FC236}">
-                <a16:creationId xmlns:a16="http://schemas.microsoft.com/office/drawing/2014/main" id="{979D211C-B4E5-B03B-B5E3-7C3DDD2648FA}"/>
-              </a:ext>
-            </a:extLst>
-          </p:cNvPr>
-          <p:cNvSpPr>
-            <a:spLocks noGrp="1"/>
-          </p:cNvSpPr>
-          <p:nvPr>
-            <p:ph idx="1"/>
-          </p:nvPr>
-        </p:nvSpPr>
-        <p:spPr/>
-        <p:txBody>
-          <a:bodyPr/>
-          <a:lstStyle/>
-          <a:p>
-            <a:endParaRPr lang="en-US"/>
-          </a:p>
-        </p:txBody>
-      </p:sp>
-    </p:spTree>
-    <p:extLst>
-      <p:ext uri="{BB962C8B-B14F-4D97-AF65-F5344CB8AC3E}">
-        <p14:creationId xmlns:p14="http://schemas.microsoft.com/office/powerpoint/2010/main" val="871395411"/>
       </p:ext>
     </p:extLst>
   </p:cSld>
@@ -4509,4 +5774,319 @@
     </a:ext>
   </a:extLst>
 </a:theme>
+</file>
+
+<file path=ppt/theme/theme2.xml><?xml version="1.0" encoding="utf-8"?>
+<a:theme xmlns:a="http://schemas.openxmlformats.org/drawingml/2006/main" name="Office Theme">
+  <a:themeElements>
+    <a:clrScheme name="Office">
+      <a:dk1>
+        <a:sysClr val="windowText" lastClr="000000"/>
+      </a:dk1>
+      <a:lt1>
+        <a:sysClr val="window" lastClr="FFFFFF"/>
+      </a:lt1>
+      <a:dk2>
+        <a:srgbClr val="0E2841"/>
+      </a:dk2>
+      <a:lt2>
+        <a:srgbClr val="E8E8E8"/>
+      </a:lt2>
+      <a:accent1>
+        <a:srgbClr val="156082"/>
+      </a:accent1>
+      <a:accent2>
+        <a:srgbClr val="E97132"/>
+      </a:accent2>
+      <a:accent3>
+        <a:srgbClr val="196B24"/>
+      </a:accent3>
+      <a:accent4>
+        <a:srgbClr val="0F9ED5"/>
+      </a:accent4>
+      <a:accent5>
+        <a:srgbClr val="A02B93"/>
+      </a:accent5>
+      <a:accent6>
+        <a:srgbClr val="4EA72E"/>
+      </a:accent6>
+      <a:hlink>
+        <a:srgbClr val="467886"/>
+      </a:hlink>
+      <a:folHlink>
+        <a:srgbClr val="96607D"/>
+      </a:folHlink>
+    </a:clrScheme>
+    <a:fontScheme name="Office">
+      <a:majorFont>
+        <a:latin typeface="Aptos Display" panose="02110004020202020204"/>
+        <a:ea typeface=""/>
+        <a:cs typeface=""/>
+        <a:font script="Jpan" typeface="游ゴシック Light"/>
+        <a:font script="Hang" typeface="맑은 고딕"/>
+        <a:font script="Hans" typeface="等线 Light"/>
+        <a:font script="Hant" typeface="新細明體"/>
+        <a:font script="Arab" typeface="Times New Roman"/>
+        <a:font script="Hebr" typeface="Times New Roman"/>
+        <a:font script="Thai" typeface="Angsana New"/>
+        <a:font script="Ethi" typeface="Nyala"/>
+        <a:font script="Beng" typeface="Vrinda"/>
+        <a:font script="Gujr" typeface="Shruti"/>
+        <a:font script="Khmr" typeface="MoolBoran"/>
+        <a:font script="Knda" typeface="Tunga"/>
+        <a:font script="Guru" typeface="Raavi"/>
+        <a:font script="Cans" typeface="Euphemia"/>
+        <a:font script="Cher" typeface="Plantagenet Cherokee"/>
+        <a:font script="Yiii" typeface="Microsoft Yi Baiti"/>
+        <a:font script="Tibt" typeface="Microsoft Himalaya"/>
+        <a:font script="Thaa" typeface="MV Boli"/>
+        <a:font script="Deva" typeface="Mangal"/>
+        <a:font script="Telu" typeface="Gautami"/>
+        <a:font script="Taml" typeface="Latha"/>
+        <a:font script="Syrc" typeface="Estrangelo Edessa"/>
+        <a:font script="Orya" typeface="Kalinga"/>
+        <a:font script="Mlym" typeface="Kartika"/>
+        <a:font script="Laoo" typeface="DokChampa"/>
+        <a:font script="Sinh" typeface="Iskoola Pota"/>
+        <a:font script="Mong" typeface="Mongolian Baiti"/>
+        <a:font script="Viet" typeface="Times New Roman"/>
+        <a:font script="Uigh" typeface="Microsoft Uighur"/>
+        <a:font script="Geor" typeface="Sylfaen"/>
+        <a:font script="Armn" typeface="Arial"/>
+        <a:font script="Bugi" typeface="Leelawadee UI"/>
+        <a:font script="Bopo" typeface="Microsoft JhengHei"/>
+        <a:font script="Java" typeface="Javanese Text"/>
+        <a:font script="Lisu" typeface="Segoe UI"/>
+        <a:font script="Mymr" typeface="Myanmar Text"/>
+        <a:font script="Nkoo" typeface="Ebrima"/>
+        <a:font script="Olck" typeface="Nirmala UI"/>
+        <a:font script="Osma" typeface="Ebrima"/>
+        <a:font script="Phag" typeface="Phagspa"/>
+        <a:font script="Syrn" typeface="Estrangelo Edessa"/>
+        <a:font script="Syrj" typeface="Estrangelo Edessa"/>
+        <a:font script="Syre" typeface="Estrangelo Edessa"/>
+        <a:font script="Sora" typeface="Nirmala UI"/>
+        <a:font script="Tale" typeface="Microsoft Tai Le"/>
+        <a:font script="Talu" typeface="Microsoft New Tai Lue"/>
+        <a:font script="Tfng" typeface="Ebrima"/>
+      </a:majorFont>
+      <a:minorFont>
+        <a:latin typeface="Aptos" panose="02110004020202020204"/>
+        <a:ea typeface=""/>
+        <a:cs typeface=""/>
+        <a:font script="Jpan" typeface="游ゴシック"/>
+        <a:font script="Hang" typeface="맑은 고딕"/>
+        <a:font script="Hans" typeface="等线"/>
+        <a:font script="Hant" typeface="新細明體"/>
+        <a:font script="Arab" typeface="Arial"/>
+        <a:font script="Hebr" typeface="Arial"/>
+        <a:font script="Thai" typeface="Cordia New"/>
+        <a:font script="Ethi" typeface="Nyala"/>
+        <a:font script="Beng" typeface="Vrinda"/>
+        <a:font script="Gujr" typeface="Shruti"/>
+        <a:font script="Khmr" typeface="DaunPenh"/>
+        <a:font script="Knda" typeface="Tunga"/>
+        <a:font script="Guru" typeface="Raavi"/>
+        <a:font script="Cans" typeface="Euphemia"/>
+        <a:font script="Cher" typeface="Plantagenet Cherokee"/>
+        <a:font script="Yiii" typeface="Microsoft Yi Baiti"/>
+        <a:font script="Tibt" typeface="Microsoft Himalaya"/>
+        <a:font script="Thaa" typeface="MV Boli"/>
+        <a:font script="Deva" typeface="Mangal"/>
+        <a:font script="Telu" typeface="Gautami"/>
+        <a:font script="Taml" typeface="Latha"/>
+        <a:font script="Syrc" typeface="Estrangelo Edessa"/>
+        <a:font script="Orya" typeface="Kalinga"/>
+        <a:font script="Mlym" typeface="Kartika"/>
+        <a:font script="Laoo" typeface="DokChampa"/>
+        <a:font script="Sinh" typeface="Iskoola Pota"/>
+        <a:font script="Mong" typeface="Mongolian Baiti"/>
+        <a:font script="Viet" typeface="Arial"/>
+        <a:font script="Uigh" typeface="Microsoft Uighur"/>
+        <a:font script="Geor" typeface="Sylfaen"/>
+        <a:font script="Armn" typeface="Arial"/>
+        <a:font script="Bugi" typeface="Leelawadee UI"/>
+        <a:font script="Bopo" typeface="Microsoft JhengHei"/>
+        <a:font script="Java" typeface="Javanese Text"/>
+        <a:font script="Lisu" typeface="Segoe UI"/>
+        <a:font script="Mymr" typeface="Myanmar Text"/>
+        <a:font script="Nkoo" typeface="Ebrima"/>
+        <a:font script="Olck" typeface="Nirmala UI"/>
+        <a:font script="Osma" typeface="Ebrima"/>
+        <a:font script="Phag" typeface="Phagspa"/>
+        <a:font script="Syrn" typeface="Estrangelo Edessa"/>
+        <a:font script="Syrj" typeface="Estrangelo Edessa"/>
+        <a:font script="Syre" typeface="Estrangelo Edessa"/>
+        <a:font script="Sora" typeface="Nirmala UI"/>
+        <a:font script="Tale" typeface="Microsoft Tai Le"/>
+        <a:font script="Talu" typeface="Microsoft New Tai Lue"/>
+        <a:font script="Tfng" typeface="Ebrima"/>
+      </a:minorFont>
+    </a:fontScheme>
+    <a:fmtScheme name="Office">
+      <a:fillStyleLst>
+        <a:solidFill>
+          <a:schemeClr val="phClr"/>
+        </a:solidFill>
+        <a:gradFill rotWithShape="1">
+          <a:gsLst>
+            <a:gs pos="0">
+              <a:schemeClr val="phClr">
+                <a:lumMod val="110000"/>
+                <a:satMod val="105000"/>
+                <a:tint val="67000"/>
+              </a:schemeClr>
+            </a:gs>
+            <a:gs pos="50000">
+              <a:schemeClr val="phClr">
+                <a:lumMod val="105000"/>
+                <a:satMod val="103000"/>
+                <a:tint val="73000"/>
+              </a:schemeClr>
+            </a:gs>
+            <a:gs pos="100000">
+              <a:schemeClr val="phClr">
+                <a:lumMod val="105000"/>
+                <a:satMod val="109000"/>
+                <a:tint val="81000"/>
+              </a:schemeClr>
+            </a:gs>
+          </a:gsLst>
+          <a:lin ang="5400000" scaled="0"/>
+        </a:gradFill>
+        <a:gradFill rotWithShape="1">
+          <a:gsLst>
+            <a:gs pos="0">
+              <a:schemeClr val="phClr">
+                <a:satMod val="103000"/>
+                <a:lumMod val="102000"/>
+                <a:tint val="94000"/>
+              </a:schemeClr>
+            </a:gs>
+            <a:gs pos="50000">
+              <a:schemeClr val="phClr">
+                <a:satMod val="110000"/>
+                <a:lumMod val="100000"/>
+                <a:shade val="100000"/>
+              </a:schemeClr>
+            </a:gs>
+            <a:gs pos="100000">
+              <a:schemeClr val="phClr">
+                <a:lumMod val="99000"/>
+                <a:satMod val="120000"/>
+                <a:shade val="78000"/>
+              </a:schemeClr>
+            </a:gs>
+          </a:gsLst>
+          <a:lin ang="5400000" scaled="0"/>
+        </a:gradFill>
+      </a:fillStyleLst>
+      <a:lnStyleLst>
+        <a:ln w="12700" cap="flat" cmpd="sng" algn="ctr">
+          <a:solidFill>
+            <a:schemeClr val="phClr"/>
+          </a:solidFill>
+          <a:prstDash val="solid"/>
+          <a:miter lim="800000"/>
+        </a:ln>
+        <a:ln w="19050" cap="flat" cmpd="sng" algn="ctr">
+          <a:solidFill>
+            <a:schemeClr val="phClr"/>
+          </a:solidFill>
+          <a:prstDash val="solid"/>
+          <a:miter lim="800000"/>
+        </a:ln>
+        <a:ln w="25400" cap="flat" cmpd="sng" algn="ctr">
+          <a:solidFill>
+            <a:schemeClr val="phClr"/>
+          </a:solidFill>
+          <a:prstDash val="solid"/>
+          <a:miter lim="800000"/>
+        </a:ln>
+      </a:lnStyleLst>
+      <a:effectStyleLst>
+        <a:effectStyle>
+          <a:effectLst/>
+        </a:effectStyle>
+        <a:effectStyle>
+          <a:effectLst/>
+        </a:effectStyle>
+        <a:effectStyle>
+          <a:effectLst>
+            <a:outerShdw blurRad="57150" dist="19050" dir="5400000" algn="ctr" rotWithShape="0">
+              <a:srgbClr val="000000">
+                <a:alpha val="63000"/>
+              </a:srgbClr>
+            </a:outerShdw>
+          </a:effectLst>
+        </a:effectStyle>
+      </a:effectStyleLst>
+      <a:bgFillStyleLst>
+        <a:solidFill>
+          <a:schemeClr val="phClr"/>
+        </a:solidFill>
+        <a:solidFill>
+          <a:schemeClr val="phClr">
+            <a:tint val="95000"/>
+            <a:satMod val="170000"/>
+          </a:schemeClr>
+        </a:solidFill>
+        <a:gradFill rotWithShape="1">
+          <a:gsLst>
+            <a:gs pos="0">
+              <a:schemeClr val="phClr">
+                <a:tint val="93000"/>
+                <a:satMod val="150000"/>
+                <a:shade val="98000"/>
+                <a:lumMod val="102000"/>
+              </a:schemeClr>
+            </a:gs>
+            <a:gs pos="50000">
+              <a:schemeClr val="phClr">
+                <a:tint val="98000"/>
+                <a:satMod val="130000"/>
+                <a:shade val="90000"/>
+                <a:lumMod val="103000"/>
+              </a:schemeClr>
+            </a:gs>
+            <a:gs pos="100000">
+              <a:schemeClr val="phClr">
+                <a:shade val="63000"/>
+                <a:satMod val="120000"/>
+              </a:schemeClr>
+            </a:gs>
+          </a:gsLst>
+          <a:lin ang="5400000" scaled="0"/>
+        </a:gradFill>
+      </a:bgFillStyleLst>
+    </a:fmtScheme>
+  </a:themeElements>
+  <a:objectDefaults>
+    <a:lnDef>
+      <a:spPr/>
+      <a:bodyPr/>
+      <a:lstStyle/>
+      <a:style>
+        <a:lnRef idx="2">
+          <a:schemeClr val="accent1"/>
+        </a:lnRef>
+        <a:fillRef idx="0">
+          <a:schemeClr val="accent1"/>
+        </a:fillRef>
+        <a:effectRef idx="1">
+          <a:schemeClr val="accent1"/>
+        </a:effectRef>
+        <a:fontRef idx="minor">
+          <a:schemeClr val="tx1"/>
+        </a:fontRef>
+      </a:style>
+    </a:lnDef>
+  </a:objectDefaults>
+  <a:extraClrSchemeLst/>
+  <a:extLst>
+    <a:ext uri="{05A4C25C-085E-4340-85A3-A5531E510DB2}">
+      <thm15:themeFamily xmlns:thm15="http://schemas.microsoft.com/office/thememl/2012/main" name="Office Theme" id="{2E142A2C-CD16-42D6-873A-C26D2A0506FA}" vid="{1BDDFF52-6CD6-40A5-AB3C-68EB2F1E4D0A}"/>
+    </a:ext>
+  </a:extLst>
+</a:theme>
 </file>
</xml_diff>